<commit_message>
feat: update dashboard design, diversify chart types, and update presentation
</commit_message>
<xml_diff>
--- a/EduVision_DV_Project_Presentation.pptx
+++ b/EduVision_DV_Project_Presentation.pptx
@@ -6077,6 +6077,12 @@
               </a:defRPr>
             </a:pPr>
             <a:r>
+              <a:rPr sz="1100" b="1">
+                <a:solidFill>
+                  <a:srgbClr val="10B981"/>
+                </a:solidFill>
+                <a:latin typeface="Segoe UI"/>
+              </a:rPr>
               <a:t>DASHBOARD 1: UNIVERSITY OVERVIEW</a:t>
             </a:r>
           </a:p>
@@ -6085,7 +6091,7 @@
               <a:spcBef>
                 <a:spcPts val="800"/>
               </a:spcBef>
-              <a:defRPr sz="900">
+              <a:defRPr sz="850">
                 <a:solidFill>
                   <a:srgbClr val="CBD5E1"/>
                 </a:solidFill>
@@ -6097,15 +6103,19 @@
             </a:r>
             <a:br/>
             <a:r>
-              <a:t>• Landing scorecard displaying top global rankings and geographic footprint.</a:t>
-            </a:r>
-            <a:br/>
-            <a:r>
-              <a:t>• Features 6 top KPI cards, ranked horizontal bar chart, reputation vs score scatter, and choropleth map.</a:t>
-            </a:r>
-            <a:br/>
-            <a:r>
-              <a:t>• Interlinking: Passes university_id to Dashboards 2 &amp; 3; passes country_id to Dashboard 4.</a:t>
+              <a:t>• Executive landing scorecard with Left Sidebar Navigation &amp; Filter Suite.</a:t>
+            </a:r>
+            <a:br/>
+            <a:r>
+              <a:t>• Features 6 Circular Badge KPI Cards (MIT #1, 1,503 Univs, 72.6 Avg Score, 28.7% Intl, 1:17.3 Ratio, 2.45M Pubs).</a:t>
+            </a:r>
+            <a:br/>
+            <a:r>
+              <a:t>• Visualization Suite: Ranked Bars, Multi-Line Trends, Regional Share Donut, Volume Bars, Geo Map, and Column Ratios.</a:t>
+            </a:r>
+            <a:br/>
+            <a:r>
+              <a:t>• Interlinking: Passes university_id to Dashboards 2 &amp; 3; passes country_id to Dashboard 4; 1-click Reset Filters.</a:t>
             </a:r>
           </a:p>
         </p:txBody>
@@ -6160,6 +6170,12 @@
               </a:defRPr>
             </a:pPr>
             <a:r>
+              <a:rPr sz="1100" b="1">
+                <a:solidFill>
+                  <a:srgbClr val="10B981"/>
+                </a:solidFill>
+                <a:latin typeface="Segoe UI"/>
+              </a:rPr>
               <a:t>DASHBOARD 2: RESEARCH ANALYTICS</a:t>
             </a:r>
           </a:p>
@@ -6168,7 +6184,7 @@
               <a:spcBef>
                 <a:spcPts val="800"/>
               </a:spcBef>
-              <a:defRPr sz="900">
+              <a:defRPr sz="850">
                 <a:solidFill>
                   <a:srgbClr val="CBD5E1"/>
                 </a:solidFill>
@@ -6180,15 +6196,19 @@
             </a:r>
             <a:br/>
             <a:r>
-              <a:t>• Deep-dive into institutional research environment, citations, and collaboration networks.</a:t>
-            </a:r>
-            <a:br/>
-            <a:r>
-              <a:t>• Features Research Productivity Index rankings and citation vs research scatter plot.</a:t>
-            </a:r>
-            <a:br/>
-            <a:r>
-              <a:t>• Interlinking: Pre-filtered for active university with peer benchmark reference lines.</a:t>
+              <a:t>• Deep-dive research intelligence with Left Sidebar Navigation &amp; Top Header.</a:t>
+            </a:r>
+            <a:br/>
+            <a:r>
+              <a:t>• Features 6 Circular KPI Badges (82.4 Research Score, 86.1 Velocity, 84.9 Productivity, 78.2 Collaboration, Harvard Hub, 2.45M Pubs).</a:t>
+            </a:r>
+            <a:br/>
+            <a:r>
+              <a:t>• Visualization Suite: Productivity Bars, Velocity Multi-Line, Regional Share Donut, Citation vs Score Scatter, Network Map, Regional Columns.</a:t>
+            </a:r>
+            <a:br/>
+            <a:r>
+              <a:t>• Interlinking: Pre-filtered for active university with peer benchmark reference lines; 1-click Reset Filters.</a:t>
             </a:r>
           </a:p>
         </p:txBody>
@@ -6243,6 +6263,12 @@
               </a:defRPr>
             </a:pPr>
             <a:r>
+              <a:rPr sz="1100" b="1">
+                <a:solidFill>
+                  <a:srgbClr val="10B981"/>
+                </a:solidFill>
+                <a:latin typeface="Segoe UI"/>
+              </a:rPr>
               <a:t>DASHBOARD 3: STUDENT ANALYTICS</a:t>
             </a:r>
           </a:p>
@@ -6251,7 +6277,7 @@
               <a:spcBef>
                 <a:spcPts val="800"/>
               </a:spcBef>
-              <a:defRPr sz="900">
+              <a:defRPr sz="850">
                 <a:solidFill>
                   <a:srgbClr val="CBD5E1"/>
                 </a:solidFill>
@@ -6263,15 +6289,19 @@
             </a:r>
             <a:br/>
             <a:r>
-              <a:t>• Explores campus diversity, actual faculty-to-student ratios, and gender breakdowns.</a:t>
-            </a:r>
-            <a:br/>
-            <a:r>
-              <a:t>• Features international student % histogram and students-per-staff benchmarking.</a:t>
-            </a:r>
-            <a:br/>
-            <a:r>
-              <a:t>• Interlinking: Pre-filtered for active university; cross-links to national context.</a:t>
+              <a:t>• Campus diversity &amp; faculty capacity intelligence with Left Sidebar Navigation.</a:t>
+            </a:r>
+            <a:br/>
+            <a:r>
+              <a:t>• Features 6 Circular KPI Badges (28.7% Intl Students, 1:17.3 Staff Ratio, 18.4M Total Enrollment, 51:49 Gender Parity, Macau Hub, Caltech Mentorship).</a:t>
+            </a:r>
+            <a:br/>
+            <a:r>
+              <a:t>• Visualization Suite: Diversity Leader Bars, Mobility Multi-Line, Student Share Donut, Diversity vs Score Scatter, Mobility Map, Faculty Ratio Columns.</a:t>
+            </a:r>
+            <a:br/>
+            <a:r>
+              <a:t>• Interlinking: Pre-filtered for active university; cross-links to national context; 1-click Reset Filters.</a:t>
             </a:r>
           </a:p>
         </p:txBody>
@@ -6326,6 +6356,12 @@
               </a:defRPr>
             </a:pPr>
             <a:r>
+              <a:rPr sz="1100" b="1">
+                <a:solidFill>
+                  <a:srgbClr val="10B981"/>
+                </a:solidFill>
+                <a:latin typeface="Segoe UI"/>
+              </a:rPr>
               <a:t>DASHBOARD 4: COUNTRY COMPARISON</a:t>
             </a:r>
           </a:p>
@@ -6334,7 +6370,7 @@
               <a:spcBef>
                 <a:spcPts val="800"/>
               </a:spcBef>
-              <a:defRPr sz="900">
+              <a:defRPr sz="850">
                 <a:solidFill>
                   <a:srgbClr val="CBD5E1"/>
                 </a:solidFill>
@@ -6346,15 +6382,19 @@
             </a:r>
             <a:br/>
             <a:r>
-              <a:t>• Country-level education benchmarking using World Bank EdStats indicators.</a:t>
-            </a:r>
-            <a:br/>
-            <a:r>
-              <a:t>• Features national capacity bar chart, public spend (% GDP) vs score, and enrollment trends.</a:t>
-            </a:r>
-            <a:br/>
-            <a:r>
-              <a:t>• Interlinking: Receives country_id from preceding dashboards; multi-country filter.</a:t>
+              <a:t>• Country-level macroeconomic education benchmarking with Left Sidebar Navigation.</a:t>
+            </a:r>
+            <a:br/>
+            <a:r>
+              <a:t>• Features 6 Circular KPI Badges (USA 197 Capacity, 58.4 Avg Score, 4.82% Spend % GDP, 62.4% Tertiary Rate, UK Leader, China Leader).</a:t>
+            </a:r>
+            <a:br/>
+            <a:r>
+              <a:t>• Visualization Suite: Capacity Bars, Gross Enrollment Multi-Line, Regional Share Donut, Public Spend vs Score Scatter, World Bank Systems Map, National Column Benchmarks.</a:t>
+            </a:r>
+            <a:br/>
+            <a:r>
+              <a:t>• Interlinking: Receives country_id from preceding dashboards; multi-country filter; 1-click Reset Filters.</a:t>
             </a:r>
           </a:p>
         </p:txBody>
@@ -6658,103 +6698,207 @@
               </a:defRPr>
             </a:pPr>
             <a:r>
+              <a:rPr sz="1050" b="1">
+                <a:solidFill>
+                  <a:srgbClr val="10B981"/>
+                </a:solidFill>
+                <a:latin typeface="Segoe UI"/>
+              </a:rPr>
               <a:t>DASHBOARD 1 ARCHITECTURE</a:t>
             </a:r>
           </a:p>
           <a:p>
             <a:pPr>
               <a:spcBef>
-                <a:spcPts val="800"/>
+                <a:spcPts val="600"/>
               </a:spcBef>
-              <a:defRPr sz="850">
+            </a:pPr>
+            <a:r>
+              <a:rPr sz="780" b="1">
+                <a:solidFill>
+                  <a:srgbClr val="F1F5F9"/>
+                </a:solidFill>
+                <a:latin typeface="Segoe UI"/>
+              </a:rPr>
+              <a:t>Core Business Purpose:</a:t>
+            </a:r>
+            <a:br/>
+            <a:r>
+              <a:rPr sz="750">
                 <a:solidFill>
                   <a:srgbClr val="CBD5E1"/>
                 </a:solidFill>
                 <a:latin typeface="Segoe UI"/>
-              </a:defRPr>
-            </a:pPr>
-            <a:r>
-              <a:t>Core Business Purpose:</a:t>
-            </a:r>
-            <a:br/>
-            <a:r>
-              <a:t>Executive landing page and institutional benchmark scorecard.</a:t>
+              </a:rPr>
+              <a:t>Executive landing page and institutional benchmark scorecard with persistent Left Sidebar Navigation and Top Quick Filters.</a:t>
             </a:r>
           </a:p>
           <a:p>
             <a:pPr>
               <a:spcBef>
-                <a:spcPts val="800"/>
+                <a:spcPts val="500"/>
               </a:spcBef>
-              <a:defRPr sz="850">
+            </a:pPr>
+            <a:r>
+              <a:rPr sz="780" b="1">
+                <a:solidFill>
+                  <a:srgbClr val="F1F5F9"/>
+                </a:solidFill>
+                <a:latin typeface="Segoe UI"/>
+              </a:rPr>
+              <a:t>Visual Components:</a:t>
+            </a:r>
+            <a:br/>
+            <a:r>
+              <a:rPr sz="700">
                 <a:solidFill>
                   <a:srgbClr val="CBD5E1"/>
                 </a:solidFill>
                 <a:latin typeface="Segoe UI"/>
-              </a:defRPr>
-            </a:pPr>
-            <a:r>
-              <a:t>Visual Components:</a:t>
-            </a:r>
-            <a:br/>
-            <a:r>
-              <a:t>• 6 Top KPI Executive Metric Cards</a:t>
-            </a:r>
-            <a:br/>
-            <a:r>
-              <a:t>• Global Choropleth Distribution Map</a:t>
-            </a:r>
-            <a:br/>
-            <a:r>
-              <a:t>• Ranked Horizontal Bar Chart</a:t>
-            </a:r>
-            <a:br/>
-            <a:r>
-              <a:t>• Academic Reputation vs. Overall Score Scatter Plot</a:t>
+              </a:rPr>
+              <a:t>• Left Sidebar: Active navigation pills, Year/Region/Country/Subject filters, and Reset Filters button</a:t>
+            </a:r>
+            <a:br/>
+            <a:r>
+              <a:rPr sz="700">
+                <a:solidFill>
+                  <a:srgbClr val="CBD5E1"/>
+                </a:solidFill>
+                <a:latin typeface="Segoe UI"/>
+              </a:rPr>
+              <a:t>• 6 Circular Badge KPI Cards: #1 MIT Rank, 1,503 Ranked Univs, 72.6 Avg Score, 28.7% Intl Students, 1:17.3 Ratio, 2.45M Publications</a:t>
+            </a:r>
+            <a:br/>
+            <a:r>
+              <a:rPr sz="700">
+                <a:solidFill>
+                  <a:srgbClr val="CBD5E1"/>
+                </a:solidFill>
+                <a:latin typeface="Segoe UI"/>
+              </a:rPr>
+              <a:t>• Top 10 Universities by Global Ranking (Ranked Horizontal Bars)</a:t>
+            </a:r>
+            <a:br/>
+            <a:r>
+              <a:rPr sz="700">
+                <a:solidFill>
+                  <a:srgbClr val="CBD5E1"/>
+                </a:solidFill>
+                <a:latin typeface="Segoe UI"/>
+              </a:rPr>
+              <a:t>• Top 10 Universities by Overall Score Trend (Multi-Line Chart 2020-2024)</a:t>
+            </a:r>
+            <a:br/>
+            <a:r>
+              <a:rPr sz="700">
+                <a:solidFill>
+                  <a:srgbClr val="CBD5E1"/>
+                </a:solidFill>
+                <a:latin typeface="Segoe UI"/>
+              </a:rPr>
+              <a:t>• Universities by Region (Regional Share Donut Chart with Center Total)</a:t>
+            </a:r>
+            <a:br/>
+            <a:r>
+              <a:rPr sz="700">
+                <a:solidFill>
+                  <a:srgbClr val="CBD5E1"/>
+                </a:solidFill>
+                <a:latin typeface="Segoe UI"/>
+              </a:rPr>
+              <a:t>• Publications by Top 5 Universities (Horizontal Volume Bars)</a:t>
+            </a:r>
+            <a:br/>
+            <a:r>
+              <a:rPr sz="700">
+                <a:solidFill>
+                  <a:srgbClr val="CBD5E1"/>
+                </a:solidFill>
+                <a:latin typeface="Segoe UI"/>
+              </a:rPr>
+              <a:t>• International Students % by Region (Interactive Geographic Map)</a:t>
+            </a:r>
+            <a:br/>
+            <a:r>
+              <a:rPr sz="700">
+                <a:solidFill>
+                  <a:srgbClr val="CBD5E1"/>
+                </a:solidFill>
+                <a:latin typeface="Segoe UI"/>
+              </a:rPr>
+              <a:t>• Faculty-to-Student Ratio by Region (Vertical Column Chart)</a:t>
             </a:r>
           </a:p>
           <a:p>
             <a:pPr>
               <a:spcBef>
-                <a:spcPts val="800"/>
+                <a:spcPts val="500"/>
               </a:spcBef>
-              <a:defRPr sz="850">
+            </a:pPr>
+            <a:r>
+              <a:rPr sz="780" b="1">
+                <a:solidFill>
+                  <a:srgbClr val="F1F5F9"/>
+                </a:solidFill>
+                <a:latin typeface="Segoe UI"/>
+              </a:rPr>
+              <a:t>Interactivity &amp; Filter Actions:</a:t>
+            </a:r>
+            <a:br/>
+            <a:r>
+              <a:rPr sz="700">
                 <a:solidFill>
                   <a:srgbClr val="CBD5E1"/>
                 </a:solidFill>
                 <a:latin typeface="Segoe UI"/>
-              </a:defRPr>
-            </a:pPr>
-            <a:r>
-              <a:t>Interactivity &amp; Filter Actions:</a:t>
-            </a:r>
-            <a:br/>
-            <a:r>
+              </a:rPr>
+              <a:t>• Left sidebar single/multi-select dropdowns filter all 6 views dynamically.</a:t>
+            </a:r>
+            <a:br/>
+            <a:r>
+              <a:rPr sz="700">
+                <a:solidFill>
+                  <a:srgbClr val="CBD5E1"/>
+                </a:solidFill>
+                <a:latin typeface="Segoe UI"/>
+              </a:rPr>
               <a:t>• Clicking any university filters all charts and passes university_id to Dashboards 2 &amp; 3.</a:t>
             </a:r>
             <a:br/>
             <a:r>
-              <a:t>• Regional dropdown parameter allows continuous geographic slice-and-dice.</a:t>
+              <a:rPr sz="700">
+                <a:solidFill>
+                  <a:srgbClr val="CBD5E1"/>
+                </a:solidFill>
+                <a:latin typeface="Segoe UI"/>
+              </a:rPr>
+              <a:t>• 1-click ↺ Reset Filters button restores full global view instantly.</a:t>
             </a:r>
           </a:p>
           <a:p>
             <a:pPr>
               <a:spcBef>
-                <a:spcPts val="800"/>
+                <a:spcPts val="500"/>
               </a:spcBef>
-              <a:defRPr sz="850">
+            </a:pPr>
+            <a:r>
+              <a:rPr sz="780" b="1">
+                <a:solidFill>
+                  <a:srgbClr val="F1F5F9"/>
+                </a:solidFill>
+                <a:latin typeface="Segoe UI"/>
+              </a:rPr>
+              <a:t>Analytical Finding:</a:t>
+            </a:r>
+            <a:br/>
+            <a:r>
+              <a:rPr sz="720">
                 <a:solidFill>
                   <a:srgbClr val="CBD5E1"/>
                 </a:solidFill>
                 <a:latin typeface="Segoe UI"/>
-              </a:defRPr>
-            </a:pPr>
-            <a:r>
-              <a:t>Analytical Finding:</a:t>
-            </a:r>
-            <a:br/>
-            <a:r>
-              <a:t>MIT, Imperial, and Oxford dominate top overall scores, with 40% of top 50 institutions concentrated in North America.</a:t>
+              </a:rPr>
+              <a:t>MIT, Cambridge, and Oxford lead global rankings; North America and Europe host &gt;65% of top institutions; faculty ratios range from 1:12.6 in South America to 1:21.4 in North America.</a:t>
             </a:r>
           </a:p>
         </p:txBody>
@@ -7058,103 +7202,207 @@
               </a:defRPr>
             </a:pPr>
             <a:r>
+              <a:rPr sz="1050" b="1">
+                <a:solidFill>
+                  <a:srgbClr val="0284C7"/>
+                </a:solidFill>
+                <a:latin typeface="Segoe UI"/>
+              </a:rPr>
               <a:t>DASHBOARD 2 ARCHITECTURE</a:t>
             </a:r>
           </a:p>
           <a:p>
             <a:pPr>
               <a:spcBef>
-                <a:spcPts val="800"/>
+                <a:spcPts val="600"/>
               </a:spcBef>
-              <a:defRPr sz="850">
+            </a:pPr>
+            <a:r>
+              <a:rPr sz="780" b="1">
+                <a:solidFill>
+                  <a:srgbClr val="F1F5F9"/>
+                </a:solidFill>
+                <a:latin typeface="Segoe UI"/>
+              </a:rPr>
+              <a:t>Core Business Purpose:</a:t>
+            </a:r>
+            <a:br/>
+            <a:r>
+              <a:rPr sz="750">
                 <a:solidFill>
                   <a:srgbClr val="CBD5E1"/>
                 </a:solidFill>
                 <a:latin typeface="Segoe UI"/>
-              </a:defRPr>
-            </a:pPr>
-            <a:r>
-              <a:t>Core Business Purpose:</a:t>
-            </a:r>
-            <a:br/>
-            <a:r>
-              <a:t>Deep-dive evaluation of scholarly research output and citation velocity.</a:t>
+              </a:rPr>
+              <a:t>Deep-dive research intelligence evaluating scholarly productivity, citation velocity, and cross-border research networks.</a:t>
             </a:r>
           </a:p>
           <a:p>
             <a:pPr>
               <a:spcBef>
-                <a:spcPts val="800"/>
+                <a:spcPts val="500"/>
               </a:spcBef>
-              <a:defRPr sz="850">
+            </a:pPr>
+            <a:r>
+              <a:rPr sz="780" b="1">
+                <a:solidFill>
+                  <a:srgbClr val="F1F5F9"/>
+                </a:solidFill>
+                <a:latin typeface="Segoe UI"/>
+              </a:rPr>
+              <a:t>Visual Components:</a:t>
+            </a:r>
+            <a:br/>
+            <a:r>
+              <a:rPr sz="700">
                 <a:solidFill>
                   <a:srgbClr val="CBD5E1"/>
                 </a:solidFill>
                 <a:latin typeface="Segoe UI"/>
-              </a:defRPr>
-            </a:pPr>
-            <a:r>
-              <a:t>Visual Components:</a:t>
-            </a:r>
-            <a:br/>
-            <a:r>
-              <a:t>• Top 15 Research Productivity Index Rankings</a:t>
-            </a:r>
-            <a:br/>
-            <a:r>
-              <a:t>• Citations per Faculty vs. Research Score Scatter Plot</a:t>
-            </a:r>
-            <a:br/>
-            <a:r>
-              <a:t>• International Research Network Collaboration Quadrant</a:t>
-            </a:r>
-            <a:br/>
-            <a:r>
-              <a:t>• Industry Income Metric Benchmarking</a:t>
+              </a:rPr>
+              <a:t>• Left Sidebar: Active navigation pills, Year/Region/Country/Subject filters, and Reset Filters button</a:t>
+            </a:r>
+            <a:br/>
+            <a:r>
+              <a:rPr sz="700">
+                <a:solidFill>
+                  <a:srgbClr val="CBD5E1"/>
+                </a:solidFill>
+                <a:latin typeface="Segoe UI"/>
+              </a:rPr>
+              <a:t>• 6 Circular KPI Badges: 82.4 Research Score, 86.1 Citation Velocity, 84.9 Productivity, 78.2 Collaboration, Harvard Hub, 2.45M Publications</a:t>
+            </a:r>
+            <a:br/>
+            <a:r>
+              <a:rPr sz="700">
+                <a:solidFill>
+                  <a:srgbClr val="CBD5E1"/>
+                </a:solidFill>
+                <a:latin typeface="Segoe UI"/>
+              </a:rPr>
+              <a:t>• Top Research Institutions by Productivity (Horizontal Bars)</a:t>
+            </a:r>
+            <a:br/>
+            <a:r>
+              <a:rPr sz="700">
+                <a:solidFill>
+                  <a:srgbClr val="CBD5E1"/>
+                </a:solidFill>
+                <a:latin typeface="Segoe UI"/>
+              </a:rPr>
+              <a:t>• Scholarly Citations Velocity Trend (Multi-Line Chart 2020-2024)</a:t>
+            </a:r>
+            <a:br/>
+            <a:r>
+              <a:rPr sz="700">
+                <a:solidFill>
+                  <a:srgbClr val="CBD5E1"/>
+                </a:solidFill>
+                <a:latin typeface="Segoe UI"/>
+              </a:rPr>
+              <a:t>• Scholarly Citations Share by Region (Donut Chart with Center Total)</a:t>
+            </a:r>
+            <a:br/>
+            <a:r>
+              <a:rPr sz="700">
+                <a:solidFill>
+                  <a:srgbClr val="CBD5E1"/>
+                </a:solidFill>
+                <a:latin typeface="Segoe UI"/>
+              </a:rPr>
+              <a:t>• Citation Impact vs Research Score (Scatter / Bubble Plot with Trendline)</a:t>
+            </a:r>
+            <a:br/>
+            <a:r>
+              <a:rPr sz="700">
+                <a:solidFill>
+                  <a:srgbClr val="CBD5E1"/>
+                </a:solidFill>
+                <a:latin typeface="Segoe UI"/>
+              </a:rPr>
+              <a:t>• Global Research Network Collaboration Map (Interactive Geographic Map)</a:t>
+            </a:r>
+            <a:br/>
+            <a:r>
+              <a:rPr sz="700">
+                <a:solidFill>
+                  <a:srgbClr val="CBD5E1"/>
+                </a:solidFill>
+                <a:latin typeface="Segoe UI"/>
+              </a:rPr>
+              <a:t>• Average Citations Score by Region (Vertical Column Benchmarks)</a:t>
             </a:r>
           </a:p>
           <a:p>
             <a:pPr>
               <a:spcBef>
-                <a:spcPts val="800"/>
+                <a:spcPts val="500"/>
               </a:spcBef>
-              <a:defRPr sz="850">
+            </a:pPr>
+            <a:r>
+              <a:rPr sz="780" b="1">
+                <a:solidFill>
+                  <a:srgbClr val="F1F5F9"/>
+                </a:solidFill>
+                <a:latin typeface="Segoe UI"/>
+              </a:rPr>
+              <a:t>Interactivity &amp; Filter Actions:</a:t>
+            </a:r>
+            <a:br/>
+            <a:r>
+              <a:rPr sz="700">
                 <a:solidFill>
                   <a:srgbClr val="CBD5E1"/>
                 </a:solidFill>
                 <a:latin typeface="Segoe UI"/>
-              </a:defRPr>
-            </a:pPr>
-            <a:r>
-              <a:t>Interactivity &amp; Filter Actions:</a:t>
-            </a:r>
-            <a:br/>
-            <a:r>
+              </a:rPr>
               <a:t>• University selection from Dashboard 1 highlights institution against global regression trendline.</a:t>
             </a:r>
             <a:br/>
             <a:r>
-              <a:t>• Citations slider isolates high-velocity scholarly hubs.</a:t>
+              <a:rPr sz="700">
+                <a:solidFill>
+                  <a:srgbClr val="CBD5E1"/>
+                </a:solidFill>
+                <a:latin typeface="Segoe UI"/>
+              </a:rPr>
+              <a:t>• Left sidebar filters and top quick navigation allow seamless drill-down.</a:t>
+            </a:r>
+            <a:br/>
+            <a:r>
+              <a:rPr sz="700">
+                <a:solidFill>
+                  <a:srgbClr val="CBD5E1"/>
+                </a:solidFill>
+                <a:latin typeface="Segoe UI"/>
+              </a:rPr>
+              <a:t>• 1-click ↺ Reset Filters button restores full global view instantly.</a:t>
             </a:r>
           </a:p>
           <a:p>
             <a:pPr>
               <a:spcBef>
-                <a:spcPts val="800"/>
+                <a:spcPts val="500"/>
               </a:spcBef>
-              <a:defRPr sz="850">
+            </a:pPr>
+            <a:r>
+              <a:rPr sz="780" b="1">
+                <a:solidFill>
+                  <a:srgbClr val="F1F5F9"/>
+                </a:solidFill>
+                <a:latin typeface="Segoe UI"/>
+              </a:rPr>
+              <a:t>Analytical Finding:</a:t>
+            </a:r>
+            <a:br/>
+            <a:r>
+              <a:rPr sz="720">
                 <a:solidFill>
                   <a:srgbClr val="CBD5E1"/>
                 </a:solidFill>
                 <a:latin typeface="Segoe UI"/>
-              </a:defRPr>
-            </a:pPr>
-            <a:r>
-              <a:t>Analytical Finding:</a:t>
-            </a:r>
-            <a:br/>
-            <a:r>
-              <a:t>Normalized citations per faculty reveal elite research density in specialized institutions like Caltech and ETH Zurich.</a:t>
+              </a:rPr>
+              <a:t>Harvard and MIT exhibit exponential citation velocity (&gt;98.0); Europe accounts for 38% of global citations; scatter analysis confirms strong positive correlation between baseline research productivity and citations per paper.</a:t>
             </a:r>
           </a:p>
         </p:txBody>
@@ -7458,103 +7706,207 @@
               </a:defRPr>
             </a:pPr>
             <a:r>
+              <a:rPr sz="1050" b="1">
+                <a:solidFill>
+                  <a:srgbClr val="EA580C"/>
+                </a:solidFill>
+                <a:latin typeface="Segoe UI"/>
+              </a:rPr>
               <a:t>DASHBOARD 3 ARCHITECTURE</a:t>
             </a:r>
           </a:p>
           <a:p>
             <a:pPr>
               <a:spcBef>
-                <a:spcPts val="800"/>
+                <a:spcPts val="600"/>
               </a:spcBef>
-              <a:defRPr sz="850">
+            </a:pPr>
+            <a:r>
+              <a:rPr sz="780" b="1">
+                <a:solidFill>
+                  <a:srgbClr val="F1F5F9"/>
+                </a:solidFill>
+                <a:latin typeface="Segoe UI"/>
+              </a:rPr>
+              <a:t>Core Business Purpose:</a:t>
+            </a:r>
+            <a:br/>
+            <a:r>
+              <a:rPr sz="750">
                 <a:solidFill>
                   <a:srgbClr val="CBD5E1"/>
                 </a:solidFill>
                 <a:latin typeface="Segoe UI"/>
-              </a:defRPr>
-            </a:pPr>
-            <a:r>
-              <a:t>Core Business Purpose:</a:t>
-            </a:r>
-            <a:br/>
-            <a:r>
-              <a:t>Analysis of student enrollment demographics, internationalization, and faculty capacity.</a:t>
+              </a:rPr>
+              <a:t>Comprehensive analysis of student enrollment demographics, internationalization mobility, and faculty mentorship capacity.</a:t>
             </a:r>
           </a:p>
           <a:p>
             <a:pPr>
               <a:spcBef>
-                <a:spcPts val="800"/>
+                <a:spcPts val="500"/>
               </a:spcBef>
-              <a:defRPr sz="850">
+            </a:pPr>
+            <a:r>
+              <a:rPr sz="780" b="1">
+                <a:solidFill>
+                  <a:srgbClr val="F1F5F9"/>
+                </a:solidFill>
+                <a:latin typeface="Segoe UI"/>
+              </a:rPr>
+              <a:t>Visual Components:</a:t>
+            </a:r>
+            <a:br/>
+            <a:r>
+              <a:rPr sz="700">
                 <a:solidFill>
                   <a:srgbClr val="CBD5E1"/>
                 </a:solidFill>
                 <a:latin typeface="Segoe UI"/>
-              </a:defRPr>
-            </a:pPr>
-            <a:r>
-              <a:t>Visual Components:</a:t>
-            </a:r>
-            <a:br/>
-            <a:r>
-              <a:t>• International Student Percentage Distribution</a:t>
-            </a:r>
-            <a:br/>
-            <a:r>
-              <a:t>• Students-per-Staff Faculty Ratio Benchmark</a:t>
-            </a:r>
-            <a:br/>
-            <a:r>
-              <a:t>• Female-to-Male Student Ratio Dumbbell Chart</a:t>
-            </a:r>
-            <a:br/>
-            <a:r>
-              <a:t>• Total FTE Student Headcount Distribution</a:t>
+              </a:rPr>
+              <a:t>• Left Sidebar: Active navigation pills, Year/Region/Country/Subject filters, and Reset Filters button</a:t>
+            </a:r>
+            <a:br/>
+            <a:r>
+              <a:rPr sz="700">
+                <a:solidFill>
+                  <a:srgbClr val="CBD5E1"/>
+                </a:solidFill>
+                <a:latin typeface="Segoe UI"/>
+              </a:rPr>
+              <a:t>• 6 Circular KPI Badges: 28.7% Intl Students, 1:17.3 Students/Staff, 18.4M Total Enrollment, 51:49 Gender Parity, Macau Hub, Caltech Mentorship</a:t>
+            </a:r>
+            <a:br/>
+            <a:r>
+              <a:rPr sz="700">
+                <a:solidFill>
+                  <a:srgbClr val="CBD5E1"/>
+                </a:solidFill>
+                <a:latin typeface="Segoe UI"/>
+              </a:rPr>
+              <a:t>• Top 5 Campus Diversity Leaders (Horizontal Bars)</a:t>
+            </a:r>
+            <a:br/>
+            <a:r>
+              <a:rPr sz="700">
+                <a:solidFill>
+                  <a:srgbClr val="CBD5E1"/>
+                </a:solidFill>
+                <a:latin typeface="Segoe UI"/>
+              </a:rPr>
+              <a:t>• International Mobility Enrollment Trend (Multi-Line Chart 2020-2024)</a:t>
+            </a:r>
+            <a:br/>
+            <a:r>
+              <a:rPr sz="700">
+                <a:solidFill>
+                  <a:srgbClr val="CBD5E1"/>
+                </a:solidFill>
+                <a:latin typeface="Segoe UI"/>
+              </a:rPr>
+              <a:t>• Total Enrolled Students Share by Region (Donut Chart with Center Total)</a:t>
+            </a:r>
+            <a:br/>
+            <a:r>
+              <a:rPr sz="700">
+                <a:solidFill>
+                  <a:srgbClr val="CBD5E1"/>
+                </a:solidFill>
+                <a:latin typeface="Segoe UI"/>
+              </a:rPr>
+              <a:t>• Campus Diversity vs Overall Score (Scatter / Bubble Plot)</a:t>
+            </a:r>
+            <a:br/>
+            <a:r>
+              <a:rPr sz="700">
+                <a:solidFill>
+                  <a:srgbClr val="CBD5E1"/>
+                </a:solidFill>
+                <a:latin typeface="Segoe UI"/>
+              </a:rPr>
+              <a:t>• International Student Mobility Footprint (Interactive Geographic Map)</a:t>
+            </a:r>
+            <a:br/>
+            <a:r>
+              <a:rPr sz="700">
+                <a:solidFill>
+                  <a:srgbClr val="CBD5E1"/>
+                </a:solidFill>
+                <a:latin typeface="Segoe UI"/>
+              </a:rPr>
+              <a:t>• Faculty-to-Student Ratio by Region (Vertical Column Benchmarks)</a:t>
             </a:r>
           </a:p>
           <a:p>
             <a:pPr>
               <a:spcBef>
-                <a:spcPts val="800"/>
+                <a:spcPts val="500"/>
               </a:spcBef>
-              <a:defRPr sz="850">
+            </a:pPr>
+            <a:r>
+              <a:rPr sz="780" b="1">
+                <a:solidFill>
+                  <a:srgbClr val="F1F5F9"/>
+                </a:solidFill>
+                <a:latin typeface="Segoe UI"/>
+              </a:rPr>
+              <a:t>Interactivity &amp; Filter Actions:</a:t>
+            </a:r>
+            <a:br/>
+            <a:r>
+              <a:rPr sz="700">
                 <a:solidFill>
                   <a:srgbClr val="CBD5E1"/>
                 </a:solidFill>
                 <a:latin typeface="Segoe UI"/>
-              </a:defRPr>
-            </a:pPr>
-            <a:r>
-              <a:t>Interactivity &amp; Filter Actions:</a:t>
-            </a:r>
-            <a:br/>
-            <a:r>
-              <a:t>• Cross-filter by institution size (Small, Medium, Mega).</a:t>
-            </a:r>
-            <a:br/>
-            <a:r>
+              </a:rPr>
+              <a:t>• Cross-filter by institution size, region, and academic tier.</a:t>
+            </a:r>
+            <a:br/>
+            <a:r>
+              <a:rPr sz="700">
+                <a:solidFill>
+                  <a:srgbClr val="CBD5E1"/>
+                </a:solidFill>
+                <a:latin typeface="Segoe UI"/>
+              </a:rPr>
               <a:t>• Drill-down from global distribution to individual university mentorship ratio.</a:t>
+            </a:r>
+            <a:br/>
+            <a:r>
+              <a:rPr sz="700">
+                <a:solidFill>
+                  <a:srgbClr val="CBD5E1"/>
+                </a:solidFill>
+                <a:latin typeface="Segoe UI"/>
+              </a:rPr>
+              <a:t>• 1-click ↺ Reset Filters button restores full global view instantly.</a:t>
             </a:r>
           </a:p>
           <a:p>
             <a:pPr>
               <a:spcBef>
-                <a:spcPts val="800"/>
+                <a:spcPts val="500"/>
               </a:spcBef>
-              <a:defRPr sz="850">
+            </a:pPr>
+            <a:r>
+              <a:rPr sz="780" b="1">
+                <a:solidFill>
+                  <a:srgbClr val="F1F5F9"/>
+                </a:solidFill>
+                <a:latin typeface="Segoe UI"/>
+              </a:rPr>
+              <a:t>Analytical Finding:</a:t>
+            </a:r>
+            <a:br/>
+            <a:r>
+              <a:rPr sz="720">
                 <a:solidFill>
                   <a:srgbClr val="CBD5E1"/>
                 </a:solidFill>
                 <a:latin typeface="Segoe UI"/>
-              </a:defRPr>
-            </a:pPr>
-            <a:r>
-              <a:t>Analytical Finding:</a:t>
-            </a:r>
-            <a:br/>
-            <a:r>
-              <a:t>UK universities demonstrate the highest international student representation (&gt;50%), while US institutions prioritize low student-to-staff ratios.</a:t>
+              </a:rPr>
+              <a:t>Global student mobility has grown +1.8% annually; leading institutions in Macau and UK demonstrate over 70% international students; intensive mentorship (lower student-to-staff ratios) directly correlates with elite academic performance tiers.</a:t>
             </a:r>
           </a:p>
         </p:txBody>
@@ -7858,103 +8210,207 @@
               </a:defRPr>
             </a:pPr>
             <a:r>
+              <a:rPr sz="1050" b="1">
+                <a:solidFill>
+                  <a:srgbClr val="8B5CF6"/>
+                </a:solidFill>
+                <a:latin typeface="Segoe UI"/>
+              </a:rPr>
               <a:t>DASHBOARD 4 ARCHITECTURE</a:t>
             </a:r>
           </a:p>
           <a:p>
             <a:pPr>
               <a:spcBef>
-                <a:spcPts val="800"/>
+                <a:spcPts val="600"/>
               </a:spcBef>
-              <a:defRPr sz="850">
+            </a:pPr>
+            <a:r>
+              <a:rPr sz="780" b="1">
+                <a:solidFill>
+                  <a:srgbClr val="F1F5F9"/>
+                </a:solidFill>
+                <a:latin typeface="Segoe UI"/>
+              </a:rPr>
+              <a:t>Core Business Purpose:</a:t>
+            </a:r>
+            <a:br/>
+            <a:r>
+              <a:rPr sz="750">
                 <a:solidFill>
                   <a:srgbClr val="CBD5E1"/>
                 </a:solidFill>
                 <a:latin typeface="Segoe UI"/>
-              </a:defRPr>
-            </a:pPr>
-            <a:r>
-              <a:t>Core Business Purpose:</a:t>
-            </a:r>
-            <a:br/>
-            <a:r>
-              <a:t>Macroeconomic evaluation linking national educational expenditure to global university performance.</a:t>
+              </a:rPr>
+              <a:t>Macroeconomic evaluation linking national educational expenditure to global university performance and capacity.</a:t>
             </a:r>
           </a:p>
           <a:p>
             <a:pPr>
               <a:spcBef>
-                <a:spcPts val="800"/>
+                <a:spcPts val="500"/>
               </a:spcBef>
-              <a:defRPr sz="850">
+            </a:pPr>
+            <a:r>
+              <a:rPr sz="780" b="1">
+                <a:solidFill>
+                  <a:srgbClr val="F1F5F9"/>
+                </a:solidFill>
+                <a:latin typeface="Segoe UI"/>
+              </a:rPr>
+              <a:t>Visual Components:</a:t>
+            </a:r>
+            <a:br/>
+            <a:r>
+              <a:rPr sz="700">
                 <a:solidFill>
                   <a:srgbClr val="CBD5E1"/>
                 </a:solidFill>
                 <a:latin typeface="Segoe UI"/>
-              </a:defRPr>
-            </a:pPr>
-            <a:r>
-              <a:t>Visual Components:</a:t>
-            </a:r>
-            <a:br/>
-            <a:r>
-              <a:t>• National Higher Education Capacity Bar Chart</a:t>
-            </a:r>
-            <a:br/>
-            <a:r>
-              <a:t>• Public Expenditure on Education (% of GDP) vs. University Score</a:t>
-            </a:r>
-            <a:br/>
-            <a:r>
-              <a:t>• Gross Tertiary School Enrollment Trends (2010–2023)</a:t>
-            </a:r>
-            <a:br/>
-            <a:r>
-              <a:t>• World Bank Country Comparison Matrix</a:t>
+              </a:rPr>
+              <a:t>• Left Sidebar: Active navigation pills, Year/Region/Country/Subject filters, and Reset Filters button</a:t>
+            </a:r>
+            <a:br/>
+            <a:r>
+              <a:rPr sz="700">
+                <a:solidFill>
+                  <a:srgbClr val="CBD5E1"/>
+                </a:solidFill>
+                <a:latin typeface="Segoe UI"/>
+              </a:rPr>
+              <a:t>• 6 Circular KPI Badges: USA 197 Capacity, 58.4 Avg Score, 4.82% Spend % GDP, 62.4% Tertiary Rate, UK Leader, China Leader</a:t>
+            </a:r>
+            <a:br/>
+            <a:r>
+              <a:rPr sz="700">
+                <a:solidFill>
+                  <a:srgbClr val="CBD5E1"/>
+                </a:solidFill>
+                <a:latin typeface="Segoe UI"/>
+              </a:rPr>
+              <a:t>• Top 5 Nations by University Capacity (Horizontal Bars)</a:t>
+            </a:r>
+            <a:br/>
+            <a:r>
+              <a:rPr sz="700">
+                <a:solidFill>
+                  <a:srgbClr val="CBD5E1"/>
+                </a:solidFill>
+                <a:latin typeface="Segoe UI"/>
+              </a:rPr>
+              <a:t>• Gross Tertiary Enrolment Rate Trend % (Multi-Line Chart 2020-2024)</a:t>
+            </a:r>
+            <a:br/>
+            <a:r>
+              <a:rPr sz="700">
+                <a:solidFill>
+                  <a:srgbClr val="CBD5E1"/>
+                </a:solidFill>
+                <a:latin typeface="Segoe UI"/>
+              </a:rPr>
+              <a:t>• Ranked Universities by Region (Donut Chart with Center Total)</a:t>
+            </a:r>
+            <a:br/>
+            <a:r>
+              <a:rPr sz="700">
+                <a:solidFill>
+                  <a:srgbClr val="CBD5E1"/>
+                </a:solidFill>
+                <a:latin typeface="Segoe UI"/>
+              </a:rPr>
+              <a:t>• Govt Education Spend (% GDP) vs Score (Scatter / Bubble Plot)</a:t>
+            </a:r>
+            <a:br/>
+            <a:r>
+              <a:rPr sz="700">
+                <a:solidFill>
+                  <a:srgbClr val="CBD5E1"/>
+                </a:solidFill>
+                <a:latin typeface="Segoe UI"/>
+              </a:rPr>
+              <a:t>• World Bank Education Systems Map (Interactive Geographic Map)</a:t>
+            </a:r>
+            <a:br/>
+            <a:r>
+              <a:rPr sz="700">
+                <a:solidFill>
+                  <a:srgbClr val="CBD5E1"/>
+                </a:solidFill>
+                <a:latin typeface="Segoe UI"/>
+              </a:rPr>
+              <a:t>• Average University Score by Top Nation (Vertical Column Benchmarks)</a:t>
             </a:r>
           </a:p>
           <a:p>
             <a:pPr>
               <a:spcBef>
-                <a:spcPts val="800"/>
+                <a:spcPts val="500"/>
               </a:spcBef>
-              <a:defRPr sz="850">
+            </a:pPr>
+            <a:r>
+              <a:rPr sz="780" b="1">
+                <a:solidFill>
+                  <a:srgbClr val="F1F5F9"/>
+                </a:solidFill>
+                <a:latin typeface="Segoe UI"/>
+              </a:rPr>
+              <a:t>Interactivity &amp; Filter Actions:</a:t>
+            </a:r>
+            <a:br/>
+            <a:r>
+              <a:rPr sz="700">
                 <a:solidFill>
                   <a:srgbClr val="CBD5E1"/>
                 </a:solidFill>
                 <a:latin typeface="Segoe UI"/>
-              </a:defRPr>
-            </a:pPr>
-            <a:r>
-              <a:t>Interactivity &amp; Filter Actions:</a:t>
-            </a:r>
-            <a:br/>
-            <a:r>
+              </a:rPr>
               <a:t>• Clicking country on Dashboard 1 filters Dashboard 4 to national profile.</a:t>
             </a:r>
             <a:br/>
             <a:r>
+              <a:rPr sz="700">
+                <a:solidFill>
+                  <a:srgbClr val="CBD5E1"/>
+                </a:solidFill>
+                <a:latin typeface="Segoe UI"/>
+              </a:rPr>
               <a:t>• Multi-country selector enables side-by-side OECD policy comparisons.</a:t>
+            </a:r>
+            <a:br/>
+            <a:r>
+              <a:rPr sz="700">
+                <a:solidFill>
+                  <a:srgbClr val="CBD5E1"/>
+                </a:solidFill>
+                <a:latin typeface="Segoe UI"/>
+              </a:rPr>
+              <a:t>• 1-click ↺ Reset Filters button restores full global view instantly.</a:t>
             </a:r>
           </a:p>
           <a:p>
             <a:pPr>
               <a:spcBef>
-                <a:spcPts val="800"/>
+                <a:spcPts val="500"/>
               </a:spcBef>
-              <a:defRPr sz="850">
+            </a:pPr>
+            <a:r>
+              <a:rPr sz="780" b="1">
+                <a:solidFill>
+                  <a:srgbClr val="F1F5F9"/>
+                </a:solidFill>
+                <a:latin typeface="Segoe UI"/>
+              </a:rPr>
+              <a:t>Analytical Finding:</a:t>
+            </a:r>
+            <a:br/>
+            <a:r>
+              <a:rPr sz="720">
                 <a:solidFill>
                   <a:srgbClr val="CBD5E1"/>
                 </a:solidFill>
                 <a:latin typeface="Segoe UI"/>
-              </a:defRPr>
-            </a:pPr>
-            <a:r>
-              <a:t>Analytical Finding:</a:t>
-            </a:r>
-            <a:br/>
-            <a:r>
-              <a:t>High public spending (&gt;5% GDP) correlates with broad tertiary access, but elite top-50 concentration requires dedicated research funding.</a:t>
+              </a:rPr>
+              <a:t>Public tertiary education spend (&gt;4.5% GDP) correlates with higher national gross enrollment (&gt;60%); USA and UK lead in top-tier capacity, while China demonstrates the fastest rate of institutional ranking gains over 2020-2024.</a:t>
             </a:r>
           </a:p>
         </p:txBody>
@@ -8234,15 +8690,21 @@
               </a:defRPr>
             </a:pPr>
             <a:r>
+              <a:rPr sz="1100" b="1">
+                <a:solidFill>
+                  <a:srgbClr val="10B981"/>
+                </a:solidFill>
+                <a:latin typeface="Segoe UI"/>
+              </a:rPr>
               <a:t>TIER 1: MACRO DISCOVERY</a:t>
             </a:r>
           </a:p>
           <a:p>
             <a:pPr>
               <a:spcBef>
-                <a:spcPts val="1200"/>
+                <a:spcPts val="800"/>
               </a:spcBef>
-              <a:defRPr sz="950">
+              <a:defRPr sz="850">
                 <a:solidFill>
                   <a:srgbClr val="CBD5E1"/>
                 </a:solidFill>
@@ -8250,20 +8712,19 @@
               </a:defRPr>
             </a:pPr>
             <a:r>
-              <a:t>Dashboard 1: University Overview</a:t>
-            </a:r>
-            <a:br/>
-            <a:br/>
-            <a:r>
-              <a:t>• User selects region or country (e.g. 'United Kingdom').</a:t>
-            </a:r>
-            <a:br/>
-            <a:r>
-              <a:t>• Scorecard displays national averages and top institutions.</a:t>
-            </a:r>
-            <a:br/>
-            <a:r>
-              <a:t>• User clicks on a specific university (e.g. 'Imperial College London').</a:t>
+              <a:t>• Dashboard 1: University Overview</a:t>
+            </a:r>
+            <a:br/>
+            <a:r>
+              <a:t>• User selects region, country, or subject area via persistent Left Sidebar.</a:t>
+            </a:r>
+            <a:br/>
+            <a:r>
+              <a:t>• Scorecard displays top institutions, global geographic share, and KPI badges.</a:t>
+            </a:r>
+            <a:br/>
+            <a:r>
+              <a:t>• Clicking any institution filters the suite and sets active context for Tier 2.</a:t>
             </a:r>
           </a:p>
         </p:txBody>
@@ -8318,15 +8779,21 @@
               </a:defRPr>
             </a:pPr>
             <a:r>
+              <a:rPr sz="1100" b="1">
+                <a:solidFill>
+                  <a:srgbClr val="10B981"/>
+                </a:solidFill>
+                <a:latin typeface="Segoe UI"/>
+              </a:rPr>
               <a:t>TIER 2: RESEARCH DEEP DIVE</a:t>
             </a:r>
           </a:p>
           <a:p>
             <a:pPr>
               <a:spcBef>
-                <a:spcPts val="1200"/>
+                <a:spcPts val="800"/>
               </a:spcBef>
-              <a:defRPr sz="950">
+              <a:defRPr sz="850">
                 <a:solidFill>
                   <a:srgbClr val="CBD5E1"/>
                 </a:solidFill>
@@ -8334,20 +8801,19 @@
               </a:defRPr>
             </a:pPr>
             <a:r>
-              <a:t>Dashboard 2: Research Analytics</a:t>
-            </a:r>
-            <a:br/>
-            <a:br/>
-            <a:r>
-              <a:t>• Filter action automatically passes university_id.</a:t>
-            </a:r>
-            <a:br/>
-            <a:r>
-              <a:t>• Highlights Imperial's 98.3 citations score on the regression line.</a:t>
-            </a:r>
-            <a:br/>
-            <a:r>
-              <a:t>• Analyzes international collaboration networks and faculty impact.</a:t>
+              <a:t>• Dashboard 2: Research Analytics</a:t>
+            </a:r>
+            <a:br/>
+            <a:r>
+              <a:t>• Filter action automatically passes university_id to evaluate citations and output.</a:t>
+            </a:r>
+            <a:br/>
+            <a:r>
+              <a:t>• Highlights institution on citation velocity trend and scatter regression plot.</a:t>
+            </a:r>
+            <a:br/>
+            <a:r>
+              <a:t>• Scholarly publication volume benchmarks institution against regional peers.</a:t>
             </a:r>
           </a:p>
         </p:txBody>
@@ -8402,15 +8868,21 @@
               </a:defRPr>
             </a:pPr>
             <a:r>
+              <a:rPr sz="1100" b="1">
+                <a:solidFill>
+                  <a:srgbClr val="10B981"/>
+                </a:solidFill>
+                <a:latin typeface="Segoe UI"/>
+              </a:rPr>
               <a:t>TIER 3: CAMPUS EXPERIENCE</a:t>
             </a:r>
           </a:p>
           <a:p>
             <a:pPr>
               <a:spcBef>
-                <a:spcPts val="1200"/>
+                <a:spcPts val="800"/>
               </a:spcBef>
-              <a:defRPr sz="950">
+              <a:defRPr sz="850">
                 <a:solidFill>
                   <a:srgbClr val="CBD5E1"/>
                 </a:solidFill>
@@ -8418,20 +8890,19 @@
               </a:defRPr>
             </a:pPr>
             <a:r>
-              <a:t>Dashboard 3: Student Analytics</a:t>
-            </a:r>
-            <a:br/>
-            <a:br/>
-            <a:r>
-              <a:t>• Evaluates mentorship capacity: Imperial's 11.4:1 student-to-staff ratio.</a:t>
-            </a:r>
-            <a:br/>
-            <a:r>
-              <a:t>• Examines student diversity: 61.0% international enrollment.</a:t>
-            </a:r>
-            <a:br/>
-            <a:r>
-              <a:t>• Assesses gender balance across student body.</a:t>
+              <a:t>• Dashboard 3: Student Analytics</a:t>
+            </a:r>
+            <a:br/>
+            <a:r>
+              <a:t>• Evaluates campus mentorship capacity and international mobility demographics.</a:t>
+            </a:r>
+            <a:br/>
+            <a:r>
+              <a:t>• Benchmarks student-to-staff ratios against global averages (1:17.3 baseline).</a:t>
+            </a:r>
+            <a:br/>
+            <a:r>
+              <a:t>• Provides detailed gender parity indices and global student share distributions.</a:t>
             </a:r>
           </a:p>
         </p:txBody>
@@ -8486,15 +8957,21 @@
               </a:defRPr>
             </a:pPr>
             <a:r>
+              <a:rPr sz="1100" b="1">
+                <a:solidFill>
+                  <a:srgbClr val="10B981"/>
+                </a:solidFill>
+                <a:latin typeface="Segoe UI"/>
+              </a:rPr>
               <a:t>TIER 4: POLICY BENCHMARK</a:t>
             </a:r>
           </a:p>
           <a:p>
             <a:pPr>
               <a:spcBef>
-                <a:spcPts val="1200"/>
+                <a:spcPts val="800"/>
               </a:spcBef>
-              <a:defRPr sz="950">
+              <a:defRPr sz="850">
                 <a:solidFill>
                   <a:srgbClr val="CBD5E1"/>
                 </a:solidFill>
@@ -8502,20 +8979,19 @@
               </a:defRPr>
             </a:pPr>
             <a:r>
-              <a:t>Dashboard 4: Country Comparison</a:t>
-            </a:r>
-            <a:br/>
-            <a:br/>
-            <a:r>
-              <a:t>• Cross-filters to the United Kingdom national profile.</a:t>
-            </a:r>
-            <a:br/>
-            <a:r>
-              <a:t>• Evaluates UK government education spending (% of GDP).</a:t>
-            </a:r>
-            <a:br/>
-            <a:r>
-              <a:t>• Compares UK tertiary gross enrollment trajectory against European peers.</a:t>
+              <a:t>• Dashboard 4: Country Comparison</a:t>
+            </a:r>
+            <a:br/>
+            <a:r>
+              <a:t>• Cross-filters to host country national profile with World Bank EdStats indicators.</a:t>
+            </a:r>
+            <a:br/>
+            <a:r>
+              <a:t>• Evaluates public tertiary spending (% of GDP) against national capacity.</a:t>
+            </a:r>
+            <a:br/>
+            <a:r>
+              <a:t>• 1-click ↺ Reset Filters button restores global cross-comparison across all views.</a:t>
             </a:r>
           </a:p>
         </p:txBody>

</xml_diff>

<commit_message>
feat: roll back to 4-quadrant executive dashboard layout, fix action filter scoping, and update presentation
</commit_message>
<xml_diff>
--- a/EduVision_DV_Project_Presentation.pptx
+++ b/EduVision_DV_Project_Presentation.pptx
@@ -5797,7 +5797,7 @@
               </a:defRPr>
             </a:pPr>
             <a:r>
-              <a:t>Empirical Finding: Top 10 institutions maintain staff ratios under 16:1 and average citations per faculty exceeding 95.0, reflecting intense faculty mentorship.</a:t>
+              <a:t>Empirical Finding: Top 10 institutions maintain staff ratios under 16:1 and average citations per faculty exceeding 95.0, reflecting intensive faculty advising.</a:t>
             </a:r>
           </a:p>
         </p:txBody>
@@ -6077,45 +6077,19 @@
               </a:defRPr>
             </a:pPr>
             <a:r>
-              <a:rPr sz="1100" b="1">
-                <a:solidFill>
-                  <a:srgbClr val="10B981"/>
-                </a:solidFill>
-                <a:latin typeface="Segoe UI"/>
-              </a:rPr>
               <a:t>DASHBOARD 1: UNIVERSITY OVERVIEW</a:t>
             </a:r>
           </a:p>
           <a:p>
             <a:pPr>
-              <a:spcBef>
-                <a:spcPts val="800"/>
-              </a:spcBef>
               <a:defRPr sz="850">
                 <a:solidFill>
-                  <a:srgbClr val="CBD5E1"/>
-                </a:solidFill>
-                <a:latin typeface="Segoe UI"/>
-              </a:defRPr>
-            </a:pPr>
-            <a:r>
-              <a:t>• Located in Milestone 3 / Module 5 &amp; Module 6.</a:t>
-            </a:r>
-            <a:br/>
-            <a:r>
-              <a:t>• Executive landing scorecard with Left Sidebar Navigation &amp; Filter Suite.</a:t>
-            </a:r>
-            <a:br/>
-            <a:r>
-              <a:t>• Features 6 Circular Badge KPI Cards (MIT #1, 1,503 Univs, 72.6 Avg Score, 28.7% Intl, 1:17.3 Ratio, 2.45M Pubs).</a:t>
-            </a:r>
-            <a:br/>
-            <a:r>
-              <a:t>• Visualization Suite: Ranked Bars, Multi-Line Trends, Regional Share Donut, Volume Bars, Geo Map, and Column Ratios.</a:t>
-            </a:r>
-            <a:br/>
-            <a:r>
-              <a:t>• Interlinking: Passes university_id to Dashboards 2 &amp; 3; passes country_id to Dashboard 4; 1-click Reset Filters.</a:t>
+                  <a:srgbClr val="E2E8F0"/>
+                </a:solidFill>
+              </a:defRPr>
+            </a:pPr>
+            <a:r>
+              <a:t>• Located in Milestone 3 / Module 5 &amp; Module 6. • Executive landing scorecard with Top Header Navigation &amp; KPI Suite. • Features 6 Executive KPI Cards (#1 MIT, 1,503 Univs, 72.6 Avg Score, 28.7% Intl Students, 1:11.2 Faculty Ratio, 84.3 Research Impact). • Visualization Quadrants: Top 10 Global Rankings (Ranked Bars), Academic Reputation vs Score (Top 50 Scatter), Global University Footprint (Regional Bars), National Capacity Benchmark. • Interlinking: Scoped action filters with exclude parameter protect macro charts while filtering detail views.</a:t>
             </a:r>
           </a:p>
         </p:txBody>
@@ -6164,51 +6138,25 @@
             <a:pPr algn="ctr">
               <a:defRPr sz="1100" b="1">
                 <a:solidFill>
-                  <a:srgbClr val="06B6D4"/>
-                </a:solidFill>
-                <a:latin typeface="Segoe UI"/>
-              </a:defRPr>
-            </a:pPr>
-            <a:r>
-              <a:rPr sz="1100" b="1">
-                <a:solidFill>
                   <a:srgbClr val="10B981"/>
                 </a:solidFill>
                 <a:latin typeface="Segoe UI"/>
-              </a:rPr>
+              </a:defRPr>
+            </a:pPr>
+            <a:r>
               <a:t>DASHBOARD 2: RESEARCH ANALYTICS</a:t>
             </a:r>
           </a:p>
           <a:p>
             <a:pPr>
-              <a:spcBef>
-                <a:spcPts val="800"/>
-              </a:spcBef>
               <a:defRPr sz="850">
                 <a:solidFill>
-                  <a:srgbClr val="CBD5E1"/>
-                </a:solidFill>
-                <a:latin typeface="Segoe UI"/>
-              </a:defRPr>
-            </a:pPr>
-            <a:r>
-              <a:t>• Located in Milestone 3 / Module 5 &amp; Module 6.</a:t>
-            </a:r>
-            <a:br/>
-            <a:r>
-              <a:t>• Deep-dive research intelligence with Left Sidebar Navigation &amp; Top Header.</a:t>
-            </a:r>
-            <a:br/>
-            <a:r>
-              <a:t>• Features 6 Circular KPI Badges (82.4 Research Score, 86.1 Velocity, 84.9 Productivity, 78.2 Collaboration, Harvard Hub, 2.45M Pubs).</a:t>
-            </a:r>
-            <a:br/>
-            <a:r>
-              <a:t>• Visualization Suite: Productivity Bars, Velocity Multi-Line, Regional Share Donut, Citation vs Score Scatter, Network Map, Regional Columns.</a:t>
-            </a:r>
-            <a:br/>
-            <a:r>
-              <a:t>• Interlinking: Pre-filtered for active university with peer benchmark reference lines; 1-click Reset Filters.</a:t>
+                  <a:srgbClr val="E2E8F0"/>
+                </a:solidFill>
+              </a:defRPr>
+            </a:pPr>
+            <a:r>
+              <a:t>• Located in Milestone 3 / Module 5 &amp; Module 6. • Deep-dive research intelligence with Top Header Navigation. • Features 6 Research KPI Scorecards (82.4 Research Score, 86.1 Citation Impact, 84.9 Productivity Index, 78.2 Intl Collab, Harvard Hub, 99.87 Citations Leader). • Visualization Quadrants: Research Productivity Rankings (Horizontal Bars), Citation Impact vs Productivity (Top 50 Scatter), Regional Academic Performance, Regional Research Performance. • Interlinking: Seamlessly cross-filters scholarly metrics across institutional tiers.</a:t>
             </a:r>
           </a:p>
         </p:txBody>
@@ -6257,51 +6205,25 @@
             <a:pPr algn="ctr">
               <a:defRPr sz="1100" b="1">
                 <a:solidFill>
-                  <a:srgbClr val="F59E0B"/>
-                </a:solidFill>
-                <a:latin typeface="Segoe UI"/>
-              </a:defRPr>
-            </a:pPr>
-            <a:r>
-              <a:rPr sz="1100" b="1">
-                <a:solidFill>
                   <a:srgbClr val="10B981"/>
                 </a:solidFill>
                 <a:latin typeface="Segoe UI"/>
-              </a:rPr>
+              </a:defRPr>
+            </a:pPr>
+            <a:r>
               <a:t>DASHBOARD 3: STUDENT ANALYTICS</a:t>
             </a:r>
           </a:p>
           <a:p>
             <a:pPr>
-              <a:spcBef>
-                <a:spcPts val="800"/>
-              </a:spcBef>
               <a:defRPr sz="850">
                 <a:solidFill>
-                  <a:srgbClr val="CBD5E1"/>
-                </a:solidFill>
-                <a:latin typeface="Segoe UI"/>
-              </a:defRPr>
-            </a:pPr>
-            <a:r>
-              <a:t>• Located in Milestone 3 / Module 6.</a:t>
-            </a:r>
-            <a:br/>
-            <a:r>
-              <a:t>• Campus diversity &amp; faculty capacity intelligence with Left Sidebar Navigation.</a:t>
-            </a:r>
-            <a:br/>
-            <a:r>
-              <a:t>• Features 6 Circular KPI Badges (28.7% Intl Students, 1:17.3 Staff Ratio, 18.4M Total Enrollment, 51:49 Gender Parity, Macau Hub, Caltech Mentorship).</a:t>
-            </a:r>
-            <a:br/>
-            <a:r>
-              <a:t>• Visualization Suite: Diversity Leader Bars, Mobility Multi-Line, Student Share Donut, Diversity vs Score Scatter, Mobility Map, Faculty Ratio Columns.</a:t>
-            </a:r>
-            <a:br/>
-            <a:r>
-              <a:t>• Interlinking: Pre-filtered for active university; cross-links to national context; 1-click Reset Filters.</a:t>
+                  <a:srgbClr val="E2E8F0"/>
+                </a:solidFill>
+              </a:defRPr>
+            </a:pPr>
+            <a:r>
+              <a:t>• Located in Milestone 3 / Module 6. • Campus diversity &amp; faculty capacity intelligence with Top Header Navigation. • Features 6 Student KPI Cards (28.7% Intl Students, 1:11.2 Faculty Ratio, 18.4M Total Enrollment, 51:49 Gender Parity, Macau Diversity Hub, Caltech Faculty Ratio). • Visualization Quadrants: Top 10 Campus Diversity (Ranked Bars), Students Per Faculty Benchmark, International Student Percentage by Region, Regional Academic Performance. • Interlinking: Evaluates institutional diversity and academic guidance across global cohorts.</a:t>
             </a:r>
           </a:p>
         </p:txBody>
@@ -6350,51 +6272,25 @@
             <a:pPr algn="ctr">
               <a:defRPr sz="1100" b="1">
                 <a:solidFill>
-                  <a:srgbClr val="8B5CF6"/>
-                </a:solidFill>
-                <a:latin typeface="Segoe UI"/>
-              </a:defRPr>
-            </a:pPr>
-            <a:r>
-              <a:rPr sz="1100" b="1">
-                <a:solidFill>
                   <a:srgbClr val="10B981"/>
                 </a:solidFill>
                 <a:latin typeface="Segoe UI"/>
-              </a:rPr>
+              </a:defRPr>
+            </a:pPr>
+            <a:r>
               <a:t>DASHBOARD 4: COUNTRY COMPARISON</a:t>
             </a:r>
           </a:p>
           <a:p>
             <a:pPr>
-              <a:spcBef>
-                <a:spcPts val="800"/>
-              </a:spcBef>
               <a:defRPr sz="850">
                 <a:solidFill>
-                  <a:srgbClr val="CBD5E1"/>
-                </a:solidFill>
-                <a:latin typeface="Segoe UI"/>
-              </a:defRPr>
-            </a:pPr>
-            <a:r>
-              <a:t>• Located in Milestone 3 / Module 6.</a:t>
-            </a:r>
-            <a:br/>
-            <a:r>
-              <a:t>• Country-level macroeconomic education benchmarking with Left Sidebar Navigation.</a:t>
-            </a:r>
-            <a:br/>
-            <a:r>
-              <a:t>• Features 6 Circular KPI Badges (USA 197 Capacity, 58.4 Avg Score, 4.82% Spend % GDP, 62.4% Tertiary Rate, UK Leader, China Leader).</a:t>
-            </a:r>
-            <a:br/>
-            <a:r>
-              <a:t>• Visualization Suite: Capacity Bars, Gross Enrollment Multi-Line, Regional Share Donut, Public Spend vs Score Scatter, World Bank Systems Map, National Column Benchmarks.</a:t>
-            </a:r>
-            <a:br/>
-            <a:r>
-              <a:t>• Interlinking: Receives country_id from preceding dashboards; multi-country filter; 1-click Reset Filters.</a:t>
+                  <a:srgbClr val="E2E8F0"/>
+                </a:solidFill>
+              </a:defRPr>
+            </a:pPr>
+            <a:r>
+              <a:t>• Located in Milestone 3 / Module 6. • Country-level macroeconomic education benchmarking with Top Header Navigation. • Features 6 Policy KPI Cards (US 197 Capacity, 58.4 Avg Score, 4.82% Spend % GDP, 62.4% Tertiary Rate, UK Leader, China Leader). • Visualization Quadrants: Top Nations by Number of Ranked Universities (National Capacity Bars), Average University Score by Top Nation (Quality Bars), Global University Footprint, Regional Academic Performance. • Interlinking: Evaluates public investment and university density across nations.</a:t>
             </a:r>
           </a:p>
         </p:txBody>
@@ -6624,30 +6520,6 @@
           </a:p>
         </p:txBody>
       </p:sp>
-      <p:pic>
-        <p:nvPicPr>
-          <p:cNvPr id="7" name="Picture 6" descr="dashboard_1_university_overview.png"/>
-          <p:cNvPicPr>
-            <a:picLocks noChangeAspect="1"/>
-          </p:cNvPicPr>
-          <p:nvPr/>
-        </p:nvPicPr>
-        <p:blipFill>
-          <a:blip r:embed="rId2"/>
-          <a:stretch>
-            <a:fillRect/>
-          </a:stretch>
-        </p:blipFill>
-        <p:spPr>
-          <a:xfrm>
-            <a:off x="731520" y="1371600"/>
-            <a:ext cx="6949440" cy="4343400"/>
-          </a:xfrm>
-          <a:prstGeom prst="rect">
-            <a:avLst/>
-          </a:prstGeom>
-        </p:spPr>
-      </p:pic>
       <p:sp>
         <p:nvSpPr>
           <p:cNvPr id="8" name="Rounded Rectangle 7"/>
@@ -6698,211 +6570,83 @@
               </a:defRPr>
             </a:pPr>
             <a:r>
-              <a:rPr sz="1050" b="1">
-                <a:solidFill>
-                  <a:srgbClr val="10B981"/>
-                </a:solidFill>
-                <a:latin typeface="Segoe UI"/>
-              </a:rPr>
               <a:t>DASHBOARD 1 ARCHITECTURE</a:t>
             </a:r>
           </a:p>
           <a:p>
             <a:pPr>
-              <a:spcBef>
-                <a:spcPts val="600"/>
-              </a:spcBef>
-            </a:pPr>
-            <a:r>
-              <a:rPr sz="780" b="1">
-                <a:solidFill>
-                  <a:srgbClr val="F1F5F9"/>
-                </a:solidFill>
-                <a:latin typeface="Segoe UI"/>
-              </a:rPr>
-              <a:t>Core Business Purpose:</a:t>
-            </a:r>
-            <a:br/>
-            <a:r>
-              <a:rPr sz="750">
-                <a:solidFill>
-                  <a:srgbClr val="CBD5E1"/>
-                </a:solidFill>
-                <a:latin typeface="Segoe UI"/>
-              </a:rPr>
-              <a:t>Executive landing page and institutional benchmark scorecard with persistent Left Sidebar Navigation and Top Quick Filters.</a:t>
+              <a:defRPr sz="850">
+                <a:solidFill>
+                  <a:srgbClr val="E2E8F0"/>
+                </a:solidFill>
+              </a:defRPr>
+            </a:pPr>
+            <a:r>
+              <a:t>Core Business Purpose: Executive landing scorecard providing institutional benchmarks, overall score evaluations, and global higher education footprints.</a:t>
             </a:r>
           </a:p>
           <a:p>
             <a:pPr>
-              <a:spcBef>
-                <a:spcPts val="500"/>
-              </a:spcBef>
-            </a:pPr>
-            <a:r>
-              <a:rPr sz="780" b="1">
-                <a:solidFill>
-                  <a:srgbClr val="F1F5F9"/>
-                </a:solidFill>
-                <a:latin typeface="Segoe UI"/>
-              </a:rPr>
-              <a:t>Visual Components:</a:t>
-            </a:r>
-            <a:br/>
-            <a:r>
-              <a:rPr sz="700">
-                <a:solidFill>
-                  <a:srgbClr val="CBD5E1"/>
-                </a:solidFill>
-                <a:latin typeface="Segoe UI"/>
-              </a:rPr>
-              <a:t>• Left Sidebar: Active navigation pills, Year/Region/Country/Subject filters, and Reset Filters button</a:t>
-            </a:r>
-            <a:br/>
-            <a:r>
-              <a:rPr sz="700">
-                <a:solidFill>
-                  <a:srgbClr val="CBD5E1"/>
-                </a:solidFill>
-                <a:latin typeface="Segoe UI"/>
-              </a:rPr>
-              <a:t>• 6 Circular Badge KPI Cards: #1 MIT Rank, 1,503 Ranked Univs, 72.6 Avg Score, 28.7% Intl Students, 1:17.3 Ratio, 2.45M Publications</a:t>
-            </a:r>
-            <a:br/>
-            <a:r>
-              <a:rPr sz="700">
-                <a:solidFill>
-                  <a:srgbClr val="CBD5E1"/>
-                </a:solidFill>
-                <a:latin typeface="Segoe UI"/>
-              </a:rPr>
-              <a:t>• Top 10 Universities by Global Ranking (Ranked Horizontal Bars)</a:t>
-            </a:r>
-            <a:br/>
-            <a:r>
-              <a:rPr sz="700">
-                <a:solidFill>
-                  <a:srgbClr val="CBD5E1"/>
-                </a:solidFill>
-                <a:latin typeface="Segoe UI"/>
-              </a:rPr>
-              <a:t>• Top 10 Universities by Overall Score Trend (Multi-Line Chart 2020-2024)</a:t>
-            </a:r>
-            <a:br/>
-            <a:r>
-              <a:rPr sz="700">
-                <a:solidFill>
-                  <a:srgbClr val="CBD5E1"/>
-                </a:solidFill>
-                <a:latin typeface="Segoe UI"/>
-              </a:rPr>
-              <a:t>• Universities by Region (Regional Share Donut Chart with Center Total)</a:t>
-            </a:r>
-            <a:br/>
-            <a:r>
-              <a:rPr sz="700">
-                <a:solidFill>
-                  <a:srgbClr val="CBD5E1"/>
-                </a:solidFill>
-                <a:latin typeface="Segoe UI"/>
-              </a:rPr>
-              <a:t>• Publications by Top 5 Universities (Horizontal Volume Bars)</a:t>
-            </a:r>
-            <a:br/>
-            <a:r>
-              <a:rPr sz="700">
-                <a:solidFill>
-                  <a:srgbClr val="CBD5E1"/>
-                </a:solidFill>
-                <a:latin typeface="Segoe UI"/>
-              </a:rPr>
-              <a:t>• International Students % by Region (Interactive Geographic Map)</a:t>
-            </a:r>
-            <a:br/>
-            <a:r>
-              <a:rPr sz="700">
-                <a:solidFill>
-                  <a:srgbClr val="CBD5E1"/>
-                </a:solidFill>
-                <a:latin typeface="Segoe UI"/>
-              </a:rPr>
-              <a:t>• Faculty-to-Student Ratio by Region (Vertical Column Chart)</a:t>
+              <a:defRPr sz="850">
+                <a:solidFill>
+                  <a:srgbClr val="E2E8F0"/>
+                </a:solidFill>
+              </a:defRPr>
+            </a:pPr>
+            <a:r>
+              <a:t>Visual Components: • Top Executive Header: Persistent navigation tabs across all 4 dashboards • 6 KPI Scorecards: #1 (MIT), 1,503 Total Universities, 72.6 Avg Score, 28.7% Intl Students, 1:11.2 Faculty Ratio, 84.3 Research Impact • Top Global Universities by Overall Score (Ranked Horizontal Bars) • Academic Reputation vs Research Citations (Scatter Plot Top 50) • Global University Distribution by Region (Horizontal Bars) • Top Nations by Number of Ranked Universities (National Capacity Bars)</a:t>
             </a:r>
           </a:p>
           <a:p>
             <a:pPr>
-              <a:spcBef>
-                <a:spcPts val="500"/>
-              </a:spcBef>
-            </a:pPr>
-            <a:r>
-              <a:rPr sz="780" b="1">
-                <a:solidFill>
-                  <a:srgbClr val="F1F5F9"/>
-                </a:solidFill>
-                <a:latin typeface="Segoe UI"/>
-              </a:rPr>
-              <a:t>Interactivity &amp; Filter Actions:</a:t>
-            </a:r>
-            <a:br/>
-            <a:r>
-              <a:rPr sz="700">
-                <a:solidFill>
-                  <a:srgbClr val="CBD5E1"/>
-                </a:solidFill>
-                <a:latin typeface="Segoe UI"/>
-              </a:rPr>
-              <a:t>• Left sidebar single/multi-select dropdowns filter all 6 views dynamically.</a:t>
-            </a:r>
-            <a:br/>
-            <a:r>
-              <a:rPr sz="700">
-                <a:solidFill>
-                  <a:srgbClr val="CBD5E1"/>
-                </a:solidFill>
-                <a:latin typeface="Segoe UI"/>
-              </a:rPr>
-              <a:t>• Clicking any university filters all charts and passes university_id to Dashboards 2 &amp; 3.</a:t>
-            </a:r>
-            <a:br/>
-            <a:r>
-              <a:rPr sz="700">
-                <a:solidFill>
-                  <a:srgbClr val="CBD5E1"/>
-                </a:solidFill>
-                <a:latin typeface="Segoe UI"/>
-              </a:rPr>
-              <a:t>• 1-click ↺ Reset Filters button restores full global view instantly.</a:t>
+              <a:defRPr sz="850">
+                <a:solidFill>
+                  <a:srgbClr val="E2E8F0"/>
+                </a:solidFill>
+              </a:defRPr>
+            </a:pPr>
+            <a:r>
+              <a:t>Interactivity &amp; Filter Actions: • Scoped action filters with explicit exclude parameter prevent macro charts from blanking out. Selecting a university dynamically isolates the institution on the scatter plot while preserving the regional and national benchmark bars intact.</a:t>
             </a:r>
           </a:p>
           <a:p>
             <a:pPr>
-              <a:spcBef>
-                <a:spcPts val="500"/>
-              </a:spcBef>
-            </a:pPr>
-            <a:r>
-              <a:rPr sz="780" b="1">
-                <a:solidFill>
-                  <a:srgbClr val="F1F5F9"/>
-                </a:solidFill>
-                <a:latin typeface="Segoe UI"/>
-              </a:rPr>
-              <a:t>Analytical Finding:</a:t>
-            </a:r>
-            <a:br/>
-            <a:r>
-              <a:rPr sz="720">
-                <a:solidFill>
-                  <a:srgbClr val="CBD5E1"/>
-                </a:solidFill>
-                <a:latin typeface="Segoe UI"/>
-              </a:rPr>
-              <a:t>MIT, Cambridge, and Oxford lead global rankings; North America and Europe host &gt;65% of top institutions; faculty ratios range from 1:12.6 in South America to 1:21.4 in North America.</a:t>
-            </a:r>
-          </a:p>
-        </p:txBody>
-      </p:sp>
+              <a:defRPr sz="850">
+                <a:solidFill>
+                  <a:srgbClr val="E2E8F0"/>
+                </a:solidFill>
+              </a:defRPr>
+            </a:pPr>
+            <a:r>
+              <a:t>Analytical Finding: MIT (#1), Imperial College London, and Oxford lead global rankings; North America and Europe host &gt;60% of top institutions, while Asia demonstrates rapid score acceleration.</a:t>
+            </a:r>
+          </a:p>
+        </p:txBody>
+      </p:sp>
+      <p:pic>
+        <p:nvPicPr>
+          <p:cNvPr id="9" name="Picture 8" descr="dashboard_1_university_overview.png"/>
+          <p:cNvPicPr>
+            <a:picLocks noChangeAspect="1"/>
+          </p:cNvPicPr>
+          <p:nvPr/>
+        </p:nvPicPr>
+        <p:blipFill>
+          <a:blip r:embed="rId3"/>
+          <a:stretch>
+            <a:fillRect/>
+          </a:stretch>
+        </p:blipFill>
+        <p:spPr>
+          <a:xfrm>
+            <a:off x="731520" y="1371600"/>
+            <a:ext cx="6949440" cy="4343400"/>
+          </a:xfrm>
+          <a:prstGeom prst="rect">
+            <a:avLst/>
+          </a:prstGeom>
+        </p:spPr>
+      </p:pic>
     </p:spTree>
   </p:cSld>
   <p:clrMapOvr>
@@ -7128,30 +6872,6 @@
           </a:p>
         </p:txBody>
       </p:sp>
-      <p:pic>
-        <p:nvPicPr>
-          <p:cNvPr id="7" name="Picture 6" descr="dashboard_2_research_analytics.png"/>
-          <p:cNvPicPr>
-            <a:picLocks noChangeAspect="1"/>
-          </p:cNvPicPr>
-          <p:nvPr/>
-        </p:nvPicPr>
-        <p:blipFill>
-          <a:blip r:embed="rId2"/>
-          <a:stretch>
-            <a:fillRect/>
-          </a:stretch>
-        </p:blipFill>
-        <p:spPr>
-          <a:xfrm>
-            <a:off x="731520" y="1371600"/>
-            <a:ext cx="6949440" cy="4343400"/>
-          </a:xfrm>
-          <a:prstGeom prst="rect">
-            <a:avLst/>
-          </a:prstGeom>
-        </p:spPr>
-      </p:pic>
       <p:sp>
         <p:nvSpPr>
           <p:cNvPr id="8" name="Rounded Rectangle 7"/>
@@ -7196,217 +6916,89 @@
             <a:pPr algn="ctr">
               <a:defRPr sz="1100" b="1">
                 <a:solidFill>
-                  <a:srgbClr val="06B6D4"/>
-                </a:solidFill>
-                <a:latin typeface="Segoe UI"/>
-              </a:defRPr>
-            </a:pPr>
-            <a:r>
-              <a:rPr sz="1050" b="1">
-                <a:solidFill>
-                  <a:srgbClr val="0284C7"/>
-                </a:solidFill>
-                <a:latin typeface="Segoe UI"/>
-              </a:rPr>
+                  <a:srgbClr val="10B981"/>
+                </a:solidFill>
+                <a:latin typeface="Segoe UI"/>
+              </a:defRPr>
+            </a:pPr>
+            <a:r>
               <a:t>DASHBOARD 2 ARCHITECTURE</a:t>
             </a:r>
           </a:p>
           <a:p>
             <a:pPr>
-              <a:spcBef>
-                <a:spcPts val="600"/>
-              </a:spcBef>
-            </a:pPr>
-            <a:r>
-              <a:rPr sz="780" b="1">
-                <a:solidFill>
-                  <a:srgbClr val="F1F5F9"/>
-                </a:solidFill>
-                <a:latin typeface="Segoe UI"/>
-              </a:rPr>
-              <a:t>Core Business Purpose:</a:t>
-            </a:r>
-            <a:br/>
-            <a:r>
-              <a:rPr sz="750">
-                <a:solidFill>
-                  <a:srgbClr val="CBD5E1"/>
-                </a:solidFill>
-                <a:latin typeface="Segoe UI"/>
-              </a:rPr>
-              <a:t>Deep-dive research intelligence evaluating scholarly productivity, citation velocity, and cross-border research networks.</a:t>
+              <a:defRPr sz="850">
+                <a:solidFill>
+                  <a:srgbClr val="E2E8F0"/>
+                </a:solidFill>
+              </a:defRPr>
+            </a:pPr>
+            <a:r>
+              <a:t>Core Business Purpose: Deep-dive research intelligence evaluating scholarly productivity, citation velocity, and international research collaborations across global institutions.</a:t>
             </a:r>
           </a:p>
           <a:p>
             <a:pPr>
-              <a:spcBef>
-                <a:spcPts val="500"/>
-              </a:spcBef>
-            </a:pPr>
-            <a:r>
-              <a:rPr sz="780" b="1">
-                <a:solidFill>
-                  <a:srgbClr val="F1F5F9"/>
-                </a:solidFill>
-                <a:latin typeface="Segoe UI"/>
-              </a:rPr>
-              <a:t>Visual Components:</a:t>
-            </a:r>
-            <a:br/>
-            <a:r>
-              <a:rPr sz="700">
-                <a:solidFill>
-                  <a:srgbClr val="CBD5E1"/>
-                </a:solidFill>
-                <a:latin typeface="Segoe UI"/>
-              </a:rPr>
-              <a:t>• Left Sidebar: Active navigation pills, Year/Region/Country/Subject filters, and Reset Filters button</a:t>
-            </a:r>
-            <a:br/>
-            <a:r>
-              <a:rPr sz="700">
-                <a:solidFill>
-                  <a:srgbClr val="CBD5E1"/>
-                </a:solidFill>
-                <a:latin typeface="Segoe UI"/>
-              </a:rPr>
-              <a:t>• 6 Circular KPI Badges: 82.4 Research Score, 86.1 Citation Velocity, 84.9 Productivity, 78.2 Collaboration, Harvard Hub, 2.45M Publications</a:t>
-            </a:r>
-            <a:br/>
-            <a:r>
-              <a:rPr sz="700">
-                <a:solidFill>
-                  <a:srgbClr val="CBD5E1"/>
-                </a:solidFill>
-                <a:latin typeface="Segoe UI"/>
-              </a:rPr>
-              <a:t>• Top Research Institutions by Productivity (Horizontal Bars)</a:t>
-            </a:r>
-            <a:br/>
-            <a:r>
-              <a:rPr sz="700">
-                <a:solidFill>
-                  <a:srgbClr val="CBD5E1"/>
-                </a:solidFill>
-                <a:latin typeface="Segoe UI"/>
-              </a:rPr>
-              <a:t>• Scholarly Citations Velocity Trend (Multi-Line Chart 2020-2024)</a:t>
-            </a:r>
-            <a:br/>
-            <a:r>
-              <a:rPr sz="700">
-                <a:solidFill>
-                  <a:srgbClr val="CBD5E1"/>
-                </a:solidFill>
-                <a:latin typeface="Segoe UI"/>
-              </a:rPr>
-              <a:t>• Scholarly Citations Share by Region (Donut Chart with Center Total)</a:t>
-            </a:r>
-            <a:br/>
-            <a:r>
-              <a:rPr sz="700">
-                <a:solidFill>
-                  <a:srgbClr val="CBD5E1"/>
-                </a:solidFill>
-                <a:latin typeface="Segoe UI"/>
-              </a:rPr>
-              <a:t>• Citation Impact vs Research Score (Scatter / Bubble Plot with Trendline)</a:t>
-            </a:r>
-            <a:br/>
-            <a:r>
-              <a:rPr sz="700">
-                <a:solidFill>
-                  <a:srgbClr val="CBD5E1"/>
-                </a:solidFill>
-                <a:latin typeface="Segoe UI"/>
-              </a:rPr>
-              <a:t>• Global Research Network Collaboration Map (Interactive Geographic Map)</a:t>
-            </a:r>
-            <a:br/>
-            <a:r>
-              <a:rPr sz="700">
-                <a:solidFill>
-                  <a:srgbClr val="CBD5E1"/>
-                </a:solidFill>
-                <a:latin typeface="Segoe UI"/>
-              </a:rPr>
-              <a:t>• Average Citations Score by Region (Vertical Column Benchmarks)</a:t>
+              <a:defRPr sz="850">
+                <a:solidFill>
+                  <a:srgbClr val="E2E8F0"/>
+                </a:solidFill>
+              </a:defRPr>
+            </a:pPr>
+            <a:r>
+              <a:t>Visual Components: • Top Executive Header: Persistent navigation tabs across all 4 dashboards • 6 Research KPI Scorecards: 82.4 Avg Research Score, 86.1 Avg Citation Impact, 84.9 Productivity Index, 78.2 Intl Collab, Harvard Peak Hub, 99.87 Citations Leader • Top Research Institutions by Productivity Index (Ranked Horizontal Bars) • Research Citation Impact vs Productivity (Scatter Plot Top 50) • Regional Academic Performance (Horizontal Bars) • Regional Research Performance (Research Citation Score by Region)</a:t>
             </a:r>
           </a:p>
           <a:p>
             <a:pPr>
-              <a:spcBef>
-                <a:spcPts val="500"/>
-              </a:spcBef>
-            </a:pPr>
-            <a:r>
-              <a:rPr sz="780" b="1">
-                <a:solidFill>
-                  <a:srgbClr val="F1F5F9"/>
-                </a:solidFill>
-                <a:latin typeface="Segoe UI"/>
-              </a:rPr>
-              <a:t>Interactivity &amp; Filter Actions:</a:t>
-            </a:r>
-            <a:br/>
-            <a:r>
-              <a:rPr sz="700">
-                <a:solidFill>
-                  <a:srgbClr val="CBD5E1"/>
-                </a:solidFill>
-                <a:latin typeface="Segoe UI"/>
-              </a:rPr>
-              <a:t>• University selection from Dashboard 1 highlights institution against global regression trendline.</a:t>
-            </a:r>
-            <a:br/>
-            <a:r>
-              <a:rPr sz="700">
-                <a:solidFill>
-                  <a:srgbClr val="CBD5E1"/>
-                </a:solidFill>
-                <a:latin typeface="Segoe UI"/>
-              </a:rPr>
-              <a:t>• Left sidebar filters and top quick navigation allow seamless drill-down.</a:t>
-            </a:r>
-            <a:br/>
-            <a:r>
-              <a:rPr sz="700">
-                <a:solidFill>
-                  <a:srgbClr val="CBD5E1"/>
-                </a:solidFill>
-                <a:latin typeface="Segoe UI"/>
-              </a:rPr>
-              <a:t>• 1-click ↺ Reset Filters button restores full global view instantly.</a:t>
+              <a:defRPr sz="850">
+                <a:solidFill>
+                  <a:srgbClr val="E2E8F0"/>
+                </a:solidFill>
+              </a:defRPr>
+            </a:pPr>
+            <a:r>
+              <a:t>Interactivity &amp; Filter Actions: • University selection highlights research productivity and citation impact. Cross-filtering by region isolates continent-level performance benchmarks without blanking out adjacent charts.</a:t>
             </a:r>
           </a:p>
           <a:p>
             <a:pPr>
-              <a:spcBef>
-                <a:spcPts val="500"/>
-              </a:spcBef>
-            </a:pPr>
-            <a:r>
-              <a:rPr sz="780" b="1">
-                <a:solidFill>
-                  <a:srgbClr val="F1F5F9"/>
-                </a:solidFill>
-                <a:latin typeface="Segoe UI"/>
-              </a:rPr>
-              <a:t>Analytical Finding:</a:t>
-            </a:r>
-            <a:br/>
-            <a:r>
-              <a:rPr sz="720">
-                <a:solidFill>
-                  <a:srgbClr val="CBD5E1"/>
-                </a:solidFill>
-                <a:latin typeface="Segoe UI"/>
-              </a:rPr>
-              <a:t>Harvard and MIT exhibit exponential citation velocity (&gt;98.0); Europe accounts for 38% of global citations; scatter analysis confirms strong positive correlation between baseline research productivity and citations per paper.</a:t>
-            </a:r>
-          </a:p>
-        </p:txBody>
-      </p:sp>
+              <a:defRPr sz="850">
+                <a:solidFill>
+                  <a:srgbClr val="E2E8F0"/>
+                </a:solidFill>
+              </a:defRPr>
+            </a:pPr>
+            <a:r>
+              <a:t>Analytical Finding: Harvard and MIT lead citation impact (&gt;98.0); European institutions demonstrate highest cross-border international research network scores (&gt;88.0).</a:t>
+            </a:r>
+          </a:p>
+        </p:txBody>
+      </p:sp>
+      <p:pic>
+        <p:nvPicPr>
+          <p:cNvPr id="9" name="Picture 8" descr="dashboard_2_research_analytics.png"/>
+          <p:cNvPicPr>
+            <a:picLocks noChangeAspect="1"/>
+          </p:cNvPicPr>
+          <p:nvPr/>
+        </p:nvPicPr>
+        <p:blipFill>
+          <a:blip r:embed="rId3"/>
+          <a:stretch>
+            <a:fillRect/>
+          </a:stretch>
+        </p:blipFill>
+        <p:spPr>
+          <a:xfrm>
+            <a:off x="731520" y="1371600"/>
+            <a:ext cx="6949440" cy="4343400"/>
+          </a:xfrm>
+          <a:prstGeom prst="rect">
+            <a:avLst/>
+          </a:prstGeom>
+        </p:spPr>
+      </p:pic>
     </p:spTree>
   </p:cSld>
   <p:clrMapOvr>
@@ -7632,30 +7224,6 @@
           </a:p>
         </p:txBody>
       </p:sp>
-      <p:pic>
-        <p:nvPicPr>
-          <p:cNvPr id="7" name="Picture 6" descr="dashboard_3_student_analytics.png"/>
-          <p:cNvPicPr>
-            <a:picLocks noChangeAspect="1"/>
-          </p:cNvPicPr>
-          <p:nvPr/>
-        </p:nvPicPr>
-        <p:blipFill>
-          <a:blip r:embed="rId2"/>
-          <a:stretch>
-            <a:fillRect/>
-          </a:stretch>
-        </p:blipFill>
-        <p:spPr>
-          <a:xfrm>
-            <a:off x="731520" y="1371600"/>
-            <a:ext cx="6949440" cy="4343400"/>
-          </a:xfrm>
-          <a:prstGeom prst="rect">
-            <a:avLst/>
-          </a:prstGeom>
-        </p:spPr>
-      </p:pic>
       <p:sp>
         <p:nvSpPr>
           <p:cNvPr id="8" name="Rounded Rectangle 7"/>
@@ -7700,217 +7268,89 @@
             <a:pPr algn="ctr">
               <a:defRPr sz="1100" b="1">
                 <a:solidFill>
-                  <a:srgbClr val="F59E0B"/>
-                </a:solidFill>
-                <a:latin typeface="Segoe UI"/>
-              </a:defRPr>
-            </a:pPr>
-            <a:r>
-              <a:rPr sz="1050" b="1">
-                <a:solidFill>
-                  <a:srgbClr val="EA580C"/>
-                </a:solidFill>
-                <a:latin typeface="Segoe UI"/>
-              </a:rPr>
+                  <a:srgbClr val="10B981"/>
+                </a:solidFill>
+                <a:latin typeface="Segoe UI"/>
+              </a:defRPr>
+            </a:pPr>
+            <a:r>
               <a:t>DASHBOARD 3 ARCHITECTURE</a:t>
             </a:r>
           </a:p>
           <a:p>
             <a:pPr>
-              <a:spcBef>
-                <a:spcPts val="600"/>
-              </a:spcBef>
-            </a:pPr>
-            <a:r>
-              <a:rPr sz="780" b="1">
-                <a:solidFill>
-                  <a:srgbClr val="F1F5F9"/>
-                </a:solidFill>
-                <a:latin typeface="Segoe UI"/>
-              </a:rPr>
-              <a:t>Core Business Purpose:</a:t>
-            </a:r>
-            <a:br/>
-            <a:r>
-              <a:rPr sz="750">
-                <a:solidFill>
-                  <a:srgbClr val="CBD5E1"/>
-                </a:solidFill>
-                <a:latin typeface="Segoe UI"/>
-              </a:rPr>
-              <a:t>Comprehensive analysis of student enrollment demographics, internationalization mobility, and faculty mentorship capacity.</a:t>
+              <a:defRPr sz="850">
+                <a:solidFill>
+                  <a:srgbClr val="E2E8F0"/>
+                </a:solidFill>
+              </a:defRPr>
+            </a:pPr>
+            <a:r>
+              <a:t>Core Business Purpose: Comprehensive analysis of student enrollment demographics, internationalization mobility, and academic faculty staffing capacity.</a:t>
             </a:r>
           </a:p>
           <a:p>
             <a:pPr>
-              <a:spcBef>
-                <a:spcPts val="500"/>
-              </a:spcBef>
-            </a:pPr>
-            <a:r>
-              <a:rPr sz="780" b="1">
-                <a:solidFill>
-                  <a:srgbClr val="F1F5F9"/>
-                </a:solidFill>
-                <a:latin typeface="Segoe UI"/>
-              </a:rPr>
-              <a:t>Visual Components:</a:t>
-            </a:r>
-            <a:br/>
-            <a:r>
-              <a:rPr sz="700">
-                <a:solidFill>
-                  <a:srgbClr val="CBD5E1"/>
-                </a:solidFill>
-                <a:latin typeface="Segoe UI"/>
-              </a:rPr>
-              <a:t>• Left Sidebar: Active navigation pills, Year/Region/Country/Subject filters, and Reset Filters button</a:t>
-            </a:r>
-            <a:br/>
-            <a:r>
-              <a:rPr sz="700">
-                <a:solidFill>
-                  <a:srgbClr val="CBD5E1"/>
-                </a:solidFill>
-                <a:latin typeface="Segoe UI"/>
-              </a:rPr>
-              <a:t>• 6 Circular KPI Badges: 28.7% Intl Students, 1:17.3 Students/Staff, 18.4M Total Enrollment, 51:49 Gender Parity, Macau Hub, Caltech Mentorship</a:t>
-            </a:r>
-            <a:br/>
-            <a:r>
-              <a:rPr sz="700">
-                <a:solidFill>
-                  <a:srgbClr val="CBD5E1"/>
-                </a:solidFill>
-                <a:latin typeface="Segoe UI"/>
-              </a:rPr>
-              <a:t>• Top 5 Campus Diversity Leaders (Horizontal Bars)</a:t>
-            </a:r>
-            <a:br/>
-            <a:r>
-              <a:rPr sz="700">
-                <a:solidFill>
-                  <a:srgbClr val="CBD5E1"/>
-                </a:solidFill>
-                <a:latin typeface="Segoe UI"/>
-              </a:rPr>
-              <a:t>• International Mobility Enrollment Trend (Multi-Line Chart 2020-2024)</a:t>
-            </a:r>
-            <a:br/>
-            <a:r>
-              <a:rPr sz="700">
-                <a:solidFill>
-                  <a:srgbClr val="CBD5E1"/>
-                </a:solidFill>
-                <a:latin typeface="Segoe UI"/>
-              </a:rPr>
-              <a:t>• Total Enrolled Students Share by Region (Donut Chart with Center Total)</a:t>
-            </a:r>
-            <a:br/>
-            <a:r>
-              <a:rPr sz="700">
-                <a:solidFill>
-                  <a:srgbClr val="CBD5E1"/>
-                </a:solidFill>
-                <a:latin typeface="Segoe UI"/>
-              </a:rPr>
-              <a:t>• Campus Diversity vs Overall Score (Scatter / Bubble Plot)</a:t>
-            </a:r>
-            <a:br/>
-            <a:r>
-              <a:rPr sz="700">
-                <a:solidFill>
-                  <a:srgbClr val="CBD5E1"/>
-                </a:solidFill>
-                <a:latin typeface="Segoe UI"/>
-              </a:rPr>
-              <a:t>• International Student Mobility Footprint (Interactive Geographic Map)</a:t>
-            </a:r>
-            <a:br/>
-            <a:r>
-              <a:rPr sz="700">
-                <a:solidFill>
-                  <a:srgbClr val="CBD5E1"/>
-                </a:solidFill>
-                <a:latin typeface="Segoe UI"/>
-              </a:rPr>
-              <a:t>• Faculty-to-Student Ratio by Region (Vertical Column Benchmarks)</a:t>
+              <a:defRPr sz="850">
+                <a:solidFill>
+                  <a:srgbClr val="E2E8F0"/>
+                </a:solidFill>
+              </a:defRPr>
+            </a:pPr>
+            <a:r>
+              <a:t>Visual Components: • Top Executive Header: Persistent navigation tabs across all 4 dashboards • 6 Student KPI Scorecards: 28.7% Intl Students, 1:11.2 Faculty Ratio, 18.4M Total Enrollment, 51:49 Gender Parity, Macau Diversity Hub (91%), Caltech Faculty Ratio (3.8:1) • Top Institutions by International Student Percentage (Horizontal Bars) • Students Per Faculty Benchmark by Region (Horizontal Bars) • International Student Percentage by Region (Horizontal Bars) • Regional Academic Performance (Horizontal Bars)</a:t>
             </a:r>
           </a:p>
           <a:p>
             <a:pPr>
-              <a:spcBef>
-                <a:spcPts val="500"/>
-              </a:spcBef>
-            </a:pPr>
-            <a:r>
-              <a:rPr sz="780" b="1">
-                <a:solidFill>
-                  <a:srgbClr val="F1F5F9"/>
-                </a:solidFill>
-                <a:latin typeface="Segoe UI"/>
-              </a:rPr>
-              <a:t>Interactivity &amp; Filter Actions:</a:t>
-            </a:r>
-            <a:br/>
-            <a:r>
-              <a:rPr sz="700">
-                <a:solidFill>
-                  <a:srgbClr val="CBD5E1"/>
-                </a:solidFill>
-                <a:latin typeface="Segoe UI"/>
-              </a:rPr>
-              <a:t>• Cross-filter by institution size, region, and academic tier.</a:t>
-            </a:r>
-            <a:br/>
-            <a:r>
-              <a:rPr sz="700">
-                <a:solidFill>
-                  <a:srgbClr val="CBD5E1"/>
-                </a:solidFill>
-                <a:latin typeface="Segoe UI"/>
-              </a:rPr>
-              <a:t>• Drill-down from global distribution to individual university mentorship ratio.</a:t>
-            </a:r>
-            <a:br/>
-            <a:r>
-              <a:rPr sz="700">
-                <a:solidFill>
-                  <a:srgbClr val="CBD5E1"/>
-                </a:solidFill>
-                <a:latin typeface="Segoe UI"/>
-              </a:rPr>
-              <a:t>• 1-click ↺ Reset Filters button restores full global view instantly.</a:t>
+              <a:defRPr sz="850">
+                <a:solidFill>
+                  <a:srgbClr val="E2E8F0"/>
+                </a:solidFill>
+              </a:defRPr>
+            </a:pPr>
+            <a:r>
+              <a:t>Interactivity &amp; Filter Actions: • Regional filtering dynamically compares campus diversity and faculty burden. Protected action scoping maintains full visibility across all regional benchmarks.</a:t>
             </a:r>
           </a:p>
           <a:p>
             <a:pPr>
-              <a:spcBef>
-                <a:spcPts val="500"/>
-              </a:spcBef>
-            </a:pPr>
-            <a:r>
-              <a:rPr sz="780" b="1">
-                <a:solidFill>
-                  <a:srgbClr val="F1F5F9"/>
-                </a:solidFill>
-                <a:latin typeface="Segoe UI"/>
-              </a:rPr>
-              <a:t>Analytical Finding:</a:t>
-            </a:r>
-            <a:br/>
-            <a:r>
-              <a:rPr sz="720">
-                <a:solidFill>
-                  <a:srgbClr val="CBD5E1"/>
-                </a:solidFill>
-                <a:latin typeface="Segoe UI"/>
-              </a:rPr>
-              <a:t>Global student mobility has grown +1.8% annually; leading institutions in Macau and UK demonstrate over 70% international students; intensive mentorship (lower student-to-staff ratios) directly correlates with elite academic performance tiers.</a:t>
-            </a:r>
-          </a:p>
-        </p:txBody>
-      </p:sp>
+              <a:defRPr sz="850">
+                <a:solidFill>
+                  <a:srgbClr val="E2E8F0"/>
+                </a:solidFill>
+              </a:defRPr>
+            </a:pPr>
+            <a:r>
+              <a:t>Analytical Finding: Global student mobility averages 28.7%; specialized institutions in Macau and London exceed 70% international students; elite institutions maintain favorable faculty ratios under 8:1.</a:t>
+            </a:r>
+          </a:p>
+        </p:txBody>
+      </p:sp>
+      <p:pic>
+        <p:nvPicPr>
+          <p:cNvPr id="9" name="Picture 8" descr="dashboard_3_student_analytics.png"/>
+          <p:cNvPicPr>
+            <a:picLocks noChangeAspect="1"/>
+          </p:cNvPicPr>
+          <p:nvPr/>
+        </p:nvPicPr>
+        <p:blipFill>
+          <a:blip r:embed="rId3"/>
+          <a:stretch>
+            <a:fillRect/>
+          </a:stretch>
+        </p:blipFill>
+        <p:spPr>
+          <a:xfrm>
+            <a:off x="731520" y="1371600"/>
+            <a:ext cx="6949440" cy="4343400"/>
+          </a:xfrm>
+          <a:prstGeom prst="rect">
+            <a:avLst/>
+          </a:prstGeom>
+        </p:spPr>
+      </p:pic>
     </p:spTree>
   </p:cSld>
   <p:clrMapOvr>
@@ -8136,30 +7576,6 @@
           </a:p>
         </p:txBody>
       </p:sp>
-      <p:pic>
-        <p:nvPicPr>
-          <p:cNvPr id="7" name="Picture 6" descr="dashboard_4_country_comparison.png"/>
-          <p:cNvPicPr>
-            <a:picLocks noChangeAspect="1"/>
-          </p:cNvPicPr>
-          <p:nvPr/>
-        </p:nvPicPr>
-        <p:blipFill>
-          <a:blip r:embed="rId2"/>
-          <a:stretch>
-            <a:fillRect/>
-          </a:stretch>
-        </p:blipFill>
-        <p:spPr>
-          <a:xfrm>
-            <a:off x="731520" y="1371600"/>
-            <a:ext cx="6949440" cy="4343400"/>
-          </a:xfrm>
-          <a:prstGeom prst="rect">
-            <a:avLst/>
-          </a:prstGeom>
-        </p:spPr>
-      </p:pic>
       <p:sp>
         <p:nvSpPr>
           <p:cNvPr id="8" name="Rounded Rectangle 7"/>
@@ -8204,217 +7620,89 @@
             <a:pPr algn="ctr">
               <a:defRPr sz="1100" b="1">
                 <a:solidFill>
-                  <a:srgbClr val="8B5CF6"/>
-                </a:solidFill>
-                <a:latin typeface="Segoe UI"/>
-              </a:defRPr>
-            </a:pPr>
-            <a:r>
-              <a:rPr sz="1050" b="1">
-                <a:solidFill>
-                  <a:srgbClr val="8B5CF6"/>
-                </a:solidFill>
-                <a:latin typeface="Segoe UI"/>
-              </a:rPr>
+                  <a:srgbClr val="10B981"/>
+                </a:solidFill>
+                <a:latin typeface="Segoe UI"/>
+              </a:defRPr>
+            </a:pPr>
+            <a:r>
               <a:t>DASHBOARD 4 ARCHITECTURE</a:t>
             </a:r>
           </a:p>
           <a:p>
             <a:pPr>
-              <a:spcBef>
-                <a:spcPts val="600"/>
-              </a:spcBef>
-            </a:pPr>
-            <a:r>
-              <a:rPr sz="780" b="1">
-                <a:solidFill>
-                  <a:srgbClr val="F1F5F9"/>
-                </a:solidFill>
-                <a:latin typeface="Segoe UI"/>
-              </a:rPr>
-              <a:t>Core Business Purpose:</a:t>
-            </a:r>
-            <a:br/>
-            <a:r>
-              <a:rPr sz="750">
-                <a:solidFill>
-                  <a:srgbClr val="CBD5E1"/>
-                </a:solidFill>
-                <a:latin typeface="Segoe UI"/>
-              </a:rPr>
-              <a:t>Macroeconomic evaluation linking national educational expenditure to global university performance and capacity.</a:t>
+              <a:defRPr sz="850">
+                <a:solidFill>
+                  <a:srgbClr val="E2E8F0"/>
+                </a:solidFill>
+              </a:defRPr>
+            </a:pPr>
+            <a:r>
+              <a:t>Core Business Purpose: Macroeconomic evaluation linking national education capacity, government funding, and higher education quality benchmarks.</a:t>
             </a:r>
           </a:p>
           <a:p>
             <a:pPr>
-              <a:spcBef>
-                <a:spcPts val="500"/>
-              </a:spcBef>
-            </a:pPr>
-            <a:r>
-              <a:rPr sz="780" b="1">
-                <a:solidFill>
-                  <a:srgbClr val="F1F5F9"/>
-                </a:solidFill>
-                <a:latin typeface="Segoe UI"/>
-              </a:rPr>
-              <a:t>Visual Components:</a:t>
-            </a:r>
-            <a:br/>
-            <a:r>
-              <a:rPr sz="700">
-                <a:solidFill>
-                  <a:srgbClr val="CBD5E1"/>
-                </a:solidFill>
-                <a:latin typeface="Segoe UI"/>
-              </a:rPr>
-              <a:t>• Left Sidebar: Active navigation pills, Year/Region/Country/Subject filters, and Reset Filters button</a:t>
-            </a:r>
-            <a:br/>
-            <a:r>
-              <a:rPr sz="700">
-                <a:solidFill>
-                  <a:srgbClr val="CBD5E1"/>
-                </a:solidFill>
-                <a:latin typeface="Segoe UI"/>
-              </a:rPr>
-              <a:t>• 6 Circular KPI Badges: USA 197 Capacity, 58.4 Avg Score, 4.82% Spend % GDP, 62.4% Tertiary Rate, UK Leader, China Leader</a:t>
-            </a:r>
-            <a:br/>
-            <a:r>
-              <a:rPr sz="700">
-                <a:solidFill>
-                  <a:srgbClr val="CBD5E1"/>
-                </a:solidFill>
-                <a:latin typeface="Segoe UI"/>
-              </a:rPr>
-              <a:t>• Top 5 Nations by University Capacity (Horizontal Bars)</a:t>
-            </a:r>
-            <a:br/>
-            <a:r>
-              <a:rPr sz="700">
-                <a:solidFill>
-                  <a:srgbClr val="CBD5E1"/>
-                </a:solidFill>
-                <a:latin typeface="Segoe UI"/>
-              </a:rPr>
-              <a:t>• Gross Tertiary Enrolment Rate Trend % (Multi-Line Chart 2020-2024)</a:t>
-            </a:r>
-            <a:br/>
-            <a:r>
-              <a:rPr sz="700">
-                <a:solidFill>
-                  <a:srgbClr val="CBD5E1"/>
-                </a:solidFill>
-                <a:latin typeface="Segoe UI"/>
-              </a:rPr>
-              <a:t>• Ranked Universities by Region (Donut Chart with Center Total)</a:t>
-            </a:r>
-            <a:br/>
-            <a:r>
-              <a:rPr sz="700">
-                <a:solidFill>
-                  <a:srgbClr val="CBD5E1"/>
-                </a:solidFill>
-                <a:latin typeface="Segoe UI"/>
-              </a:rPr>
-              <a:t>• Govt Education Spend (% GDP) vs Score (Scatter / Bubble Plot)</a:t>
-            </a:r>
-            <a:br/>
-            <a:r>
-              <a:rPr sz="700">
-                <a:solidFill>
-                  <a:srgbClr val="CBD5E1"/>
-                </a:solidFill>
-                <a:latin typeface="Segoe UI"/>
-              </a:rPr>
-              <a:t>• World Bank Education Systems Map (Interactive Geographic Map)</a:t>
-            </a:r>
-            <a:br/>
-            <a:r>
-              <a:rPr sz="700">
-                <a:solidFill>
-                  <a:srgbClr val="CBD5E1"/>
-                </a:solidFill>
-                <a:latin typeface="Segoe UI"/>
-              </a:rPr>
-              <a:t>• Average University Score by Top Nation (Vertical Column Benchmarks)</a:t>
+              <a:defRPr sz="850">
+                <a:solidFill>
+                  <a:srgbClr val="E2E8F0"/>
+                </a:solidFill>
+              </a:defRPr>
+            </a:pPr>
+            <a:r>
+              <a:t>Visual Components: • Top Executive Header: Persistent navigation tabs across all 4 dashboards • 6 Policy KPI Scorecards: US Top Capacity (197 Univs), 58.4 Avg National Score, 4.82% Spend % GDP, 62.4% Tertiary Rate, UK Europe Leader (90), China Asia Leader (71) • Top Nations by Number of Ranked Universities (National Capacity Bars) • Average University Score by Top Nation (National Quality Bars) • Global University Distribution by Region (Horizontal Bars) • Regional Academic Performance (Horizontal Bars)</a:t>
             </a:r>
           </a:p>
           <a:p>
             <a:pPr>
-              <a:spcBef>
-                <a:spcPts val="500"/>
-              </a:spcBef>
-            </a:pPr>
-            <a:r>
-              <a:rPr sz="780" b="1">
-                <a:solidFill>
-                  <a:srgbClr val="F1F5F9"/>
-                </a:solidFill>
-                <a:latin typeface="Segoe UI"/>
-              </a:rPr>
-              <a:t>Interactivity &amp; Filter Actions:</a:t>
-            </a:r>
-            <a:br/>
-            <a:r>
-              <a:rPr sz="700">
-                <a:solidFill>
-                  <a:srgbClr val="CBD5E1"/>
-                </a:solidFill>
-                <a:latin typeface="Segoe UI"/>
-              </a:rPr>
-              <a:t>• Clicking country on Dashboard 1 filters Dashboard 4 to national profile.</a:t>
-            </a:r>
-            <a:br/>
-            <a:r>
-              <a:rPr sz="700">
-                <a:solidFill>
-                  <a:srgbClr val="CBD5E1"/>
-                </a:solidFill>
-                <a:latin typeface="Segoe UI"/>
-              </a:rPr>
-              <a:t>• Multi-country selector enables side-by-side OECD policy comparisons.</a:t>
-            </a:r>
-            <a:br/>
-            <a:r>
-              <a:rPr sz="700">
-                <a:solidFill>
-                  <a:srgbClr val="CBD5E1"/>
-                </a:solidFill>
-                <a:latin typeface="Segoe UI"/>
-              </a:rPr>
-              <a:t>• 1-click ↺ Reset Filters button restores full global view instantly.</a:t>
+              <a:defRPr sz="850">
+                <a:solidFill>
+                  <a:srgbClr val="E2E8F0"/>
+                </a:solidFill>
+              </a:defRPr>
+            </a:pPr>
+            <a:r>
+              <a:t>Interactivity &amp; Filter Actions: • Country-level selection cross-filters national capacity and institutional quality scores. Multi-region selection reveals macroeconomic funding dynamics.</a:t>
             </a:r>
           </a:p>
           <a:p>
             <a:pPr>
-              <a:spcBef>
-                <a:spcPts val="500"/>
-              </a:spcBef>
-            </a:pPr>
-            <a:r>
-              <a:rPr sz="780" b="1">
-                <a:solidFill>
-                  <a:srgbClr val="F1F5F9"/>
-                </a:solidFill>
-                <a:latin typeface="Segoe UI"/>
-              </a:rPr>
-              <a:t>Analytical Finding:</a:t>
-            </a:r>
-            <a:br/>
-            <a:r>
-              <a:rPr sz="720">
-                <a:solidFill>
-                  <a:srgbClr val="CBD5E1"/>
-                </a:solidFill>
-                <a:latin typeface="Segoe UI"/>
-              </a:rPr>
-              <a:t>Public tertiary education spend (&gt;4.5% GDP) correlates with higher national gross enrollment (&gt;60%); USA and UK lead in top-tier capacity, while China demonstrates the fastest rate of institutional ranking gains over 2020-2024.</a:t>
-            </a:r>
-          </a:p>
-        </p:txBody>
-      </p:sp>
+              <a:defRPr sz="850">
+                <a:solidFill>
+                  <a:srgbClr val="E2E8F0"/>
+                </a:solidFill>
+              </a:defRPr>
+            </a:pPr>
+            <a:r>
+              <a:t>Analytical Finding: Public tertiary education spend (&gt;4.5% GDP) strongly correlates with top-tier university capacity; the US and UK lead institutional volume, while East Asia shows steepest enrollment growth.</a:t>
+            </a:r>
+          </a:p>
+        </p:txBody>
+      </p:sp>
+      <p:pic>
+        <p:nvPicPr>
+          <p:cNvPr id="9" name="Picture 8" descr="dashboard_4_country_comparison.png"/>
+          <p:cNvPicPr>
+            <a:picLocks noChangeAspect="1"/>
+          </p:cNvPicPr>
+          <p:nvPr/>
+        </p:nvPicPr>
+        <p:blipFill>
+          <a:blip r:embed="rId3"/>
+          <a:stretch>
+            <a:fillRect/>
+          </a:stretch>
+        </p:blipFill>
+        <p:spPr>
+          <a:xfrm>
+            <a:off x="731520" y="1371600"/>
+            <a:ext cx="6949440" cy="4343400"/>
+          </a:xfrm>
+          <a:prstGeom prst="rect">
+            <a:avLst/>
+          </a:prstGeom>
+        </p:spPr>
+      </p:pic>
     </p:spTree>
   </p:cSld>
   <p:clrMapOvr>
@@ -8690,41 +7978,19 @@
               </a:defRPr>
             </a:pPr>
             <a:r>
-              <a:rPr sz="1100" b="1">
-                <a:solidFill>
-                  <a:srgbClr val="10B981"/>
-                </a:solidFill>
-                <a:latin typeface="Segoe UI"/>
-              </a:rPr>
               <a:t>TIER 1: MACRO DISCOVERY</a:t>
             </a:r>
           </a:p>
           <a:p>
             <a:pPr>
-              <a:spcBef>
-                <a:spcPts val="800"/>
-              </a:spcBef>
               <a:defRPr sz="850">
                 <a:solidFill>
-                  <a:srgbClr val="CBD5E1"/>
-                </a:solidFill>
-                <a:latin typeface="Segoe UI"/>
-              </a:defRPr>
-            </a:pPr>
-            <a:r>
-              <a:t>• Dashboard 1: University Overview</a:t>
-            </a:r>
-            <a:br/>
-            <a:r>
-              <a:t>• User selects region, country, or subject area via persistent Left Sidebar.</a:t>
-            </a:r>
-            <a:br/>
-            <a:r>
-              <a:t>• Scorecard displays top institutions, global geographic share, and KPI badges.</a:t>
-            </a:r>
-            <a:br/>
-            <a:r>
-              <a:t>• Clicking any institution filters the suite and sets active context for Tier 2.</a:t>
+                  <a:srgbClr val="E2E8F0"/>
+                </a:solidFill>
+              </a:defRPr>
+            </a:pPr>
+            <a:r>
+              <a:t>• Dashboard 1: University Overview • User explores global higher education landscape via Top Navigation Tabs. • Scorecard displays top institutions, global geographic share, and 6 executive KPI cards. • Clicking an institution filters detail views while scoped exclude protection keeps macro charts intact.</a:t>
             </a:r>
           </a:p>
         </p:txBody>
@@ -8773,47 +8039,25 @@
             <a:pPr algn="ctr">
               <a:defRPr sz="1100" b="1">
                 <a:solidFill>
-                  <a:srgbClr val="06B6D4"/>
-                </a:solidFill>
-                <a:latin typeface="Segoe UI"/>
-              </a:defRPr>
-            </a:pPr>
-            <a:r>
-              <a:rPr sz="1100" b="1">
-                <a:solidFill>
                   <a:srgbClr val="10B981"/>
                 </a:solidFill>
                 <a:latin typeface="Segoe UI"/>
-              </a:rPr>
+              </a:defRPr>
+            </a:pPr>
+            <a:r>
               <a:t>TIER 2: RESEARCH DEEP DIVE</a:t>
             </a:r>
           </a:p>
           <a:p>
             <a:pPr>
-              <a:spcBef>
-                <a:spcPts val="800"/>
-              </a:spcBef>
               <a:defRPr sz="850">
                 <a:solidFill>
-                  <a:srgbClr val="CBD5E1"/>
-                </a:solidFill>
-                <a:latin typeface="Segoe UI"/>
-              </a:defRPr>
-            </a:pPr>
-            <a:r>
-              <a:t>• Dashboard 2: Research Analytics</a:t>
-            </a:r>
-            <a:br/>
-            <a:r>
-              <a:t>• Filter action automatically passes university_id to evaluate citations and output.</a:t>
-            </a:r>
-            <a:br/>
-            <a:r>
-              <a:t>• Highlights institution on citation velocity trend and scatter regression plot.</a:t>
-            </a:r>
-            <a:br/>
-            <a:r>
-              <a:t>• Scholarly publication volume benchmarks institution against regional peers.</a:t>
+                  <a:srgbClr val="E2E8F0"/>
+                </a:solidFill>
+              </a:defRPr>
+            </a:pPr>
+            <a:r>
+              <a:t>• Dashboard 2: Research Analytics • Cross-filtering evaluates research productivity and citation impact. • Highlights institution on the citation impact vs productivity scatter plot. • Regional benchmarks evaluate scholarly performance across continental peers.</a:t>
             </a:r>
           </a:p>
         </p:txBody>
@@ -8862,47 +8106,25 @@
             <a:pPr algn="ctr">
               <a:defRPr sz="1100" b="1">
                 <a:solidFill>
-                  <a:srgbClr val="F59E0B"/>
-                </a:solidFill>
-                <a:latin typeface="Segoe UI"/>
-              </a:defRPr>
-            </a:pPr>
-            <a:r>
-              <a:rPr sz="1100" b="1">
-                <a:solidFill>
                   <a:srgbClr val="10B981"/>
                 </a:solidFill>
                 <a:latin typeface="Segoe UI"/>
-              </a:rPr>
+              </a:defRPr>
+            </a:pPr>
+            <a:r>
               <a:t>TIER 3: CAMPUS EXPERIENCE</a:t>
             </a:r>
           </a:p>
           <a:p>
             <a:pPr>
-              <a:spcBef>
-                <a:spcPts val="800"/>
-              </a:spcBef>
               <a:defRPr sz="850">
                 <a:solidFill>
-                  <a:srgbClr val="CBD5E1"/>
-                </a:solidFill>
-                <a:latin typeface="Segoe UI"/>
-              </a:defRPr>
-            </a:pPr>
-            <a:r>
-              <a:t>• Dashboard 3: Student Analytics</a:t>
-            </a:r>
-            <a:br/>
-            <a:r>
-              <a:t>• Evaluates campus mentorship capacity and international mobility demographics.</a:t>
-            </a:r>
-            <a:br/>
-            <a:r>
-              <a:t>• Benchmarks student-to-staff ratios against global averages (1:17.3 baseline).</a:t>
-            </a:r>
-            <a:br/>
-            <a:r>
-              <a:t>• Provides detailed gender parity indices and global student share distributions.</a:t>
+                  <a:srgbClr val="E2E8F0"/>
+                </a:solidFill>
+              </a:defRPr>
+            </a:pPr>
+            <a:r>
+              <a:t>• Dashboard 3: Student Analytics • Evaluates campus faculty capacity and international mobility demographics. • Benchmarks faculty-to-student ratios against global benchmarks (1:11.2 baseline). • Analyzes student diversity indices and continental student distributions.</a:t>
             </a:r>
           </a:p>
         </p:txBody>
@@ -8951,47 +8173,25 @@
             <a:pPr algn="ctr">
               <a:defRPr sz="1100" b="1">
                 <a:solidFill>
-                  <a:srgbClr val="8B5CF6"/>
-                </a:solidFill>
-                <a:latin typeface="Segoe UI"/>
-              </a:defRPr>
-            </a:pPr>
-            <a:r>
-              <a:rPr sz="1100" b="1">
-                <a:solidFill>
                   <a:srgbClr val="10B981"/>
                 </a:solidFill>
                 <a:latin typeface="Segoe UI"/>
-              </a:rPr>
+              </a:defRPr>
+            </a:pPr>
+            <a:r>
               <a:t>TIER 4: POLICY BENCHMARK</a:t>
             </a:r>
           </a:p>
           <a:p>
             <a:pPr>
-              <a:spcBef>
-                <a:spcPts val="800"/>
-              </a:spcBef>
               <a:defRPr sz="850">
                 <a:solidFill>
-                  <a:srgbClr val="CBD5E1"/>
-                </a:solidFill>
-                <a:latin typeface="Segoe UI"/>
-              </a:defRPr>
-            </a:pPr>
-            <a:r>
-              <a:t>• Dashboard 4: Country Comparison</a:t>
-            </a:r>
-            <a:br/>
-            <a:r>
-              <a:t>• Cross-filters to host country national profile with World Bank EdStats indicators.</a:t>
-            </a:r>
-            <a:br/>
-            <a:r>
-              <a:t>• Evaluates public tertiary spending (% of GDP) against national capacity.</a:t>
-            </a:r>
-            <a:br/>
-            <a:r>
-              <a:t>• 1-click ↺ Reset Filters button restores global cross-comparison across all views.</a:t>
+                  <a:srgbClr val="E2E8F0"/>
+                </a:solidFill>
+              </a:defRPr>
+            </a:pPr>
+            <a:r>
+              <a:t>• Dashboard 4: Country Comparison • Cross-filters to host country national profile with macroeconomic indicators. • Evaluates public tertiary spending against top national university capacity. • Persistent top navigation allows instant transitions across all analytical tiers.</a:t>
             </a:r>
           </a:p>
         </p:txBody>
@@ -13029,7 +12229,7 @@
               </a:defRPr>
             </a:pPr>
             <a:r>
-              <a:t>• Academic leaders lack unified intelligence to evaluate research impact alongside student mentorship capacity.</a:t>
+              <a:t>• Academic leaders lack unified intelligence to evaluate research impact alongside faculty advising capacity.</a:t>
             </a:r>
             <a:br/>
             <a:r>
@@ -16695,7 +15895,7 @@
             <a:br/>
             <a:br/>
             <a:r>
-              <a:t>A lower ratio indicates intensive faculty mentorship and smaller tutorial class cohorts (e.g., Caltech: 6.4:1).</a:t>
+              <a:t>A lower ratio indicates intensive faculty advising and smaller tutorial class cohorts (e.g., Caltech: 6.4:1).</a:t>
             </a:r>
           </a:p>
         </p:txBody>

</xml_diff>